<commit_message>
Add executive cut and one-pager; switch decks to Calibri
- Switch presentation font to Calibri (PowerPoint default) so all decks
  render correctly on any machine, with no Inter dependency.
- Add Cortex-Atlas-Executive-Cut.pptx: a 9-slide leadership cut for a
  10-15 minute conversation or pre-read, with speaker notes.
- Add Cortex-Atlas-One-Pager.pptx: a single portrait (Letter) leave-behind
  summarising the challenge, solution, value, proof points and next steps.
- Add build_exec.py and build_onepager.py build scripts.

All decks are branded to the Cortex design language and use synthetic data.

Co-Authored-By: Claude Opus 4.8 <noreply@anthropic.com>
Claude-Session: https://claude.ai/code/session_01EkTNv5fSvPCcwfoWAKzSp4
</commit_message>
<xml_diff>
--- a/Cortex-Atlas-Client-Deck.pptx
+++ b/Cortex-Atlas-Client-Deck.pptx
@@ -5205,7 +5205,7 @@
                 <a:solidFill>
                   <a:srgbClr val="F89739"/>
                 </a:solidFill>
-                <a:latin typeface="Inter"/>
+                <a:latin typeface="Calibri"/>
               </a:rPr>
               <a:t>C O R T E X   S U I T E</a:t>
             </a:r>
@@ -5247,7 +5247,7 @@
                 <a:solidFill>
                   <a:srgbClr val="FFFFFF"/>
                 </a:solidFill>
-                <a:latin typeface="Inter"/>
+                <a:latin typeface="Calibri"/>
               </a:rPr>
               <a:t>Cortex Atlas</a:t>
             </a:r>
@@ -5289,7 +5289,7 @@
                 <a:solidFill>
                   <a:srgbClr val="C7CCD3"/>
                 </a:solidFill>
-                <a:latin typeface="Inter"/>
+                <a:latin typeface="Calibri"/>
               </a:rPr>
               <a:t>Commercial data governance, connected.</a:t>
             </a:r>
@@ -5331,7 +5331,7 @@
                 <a:solidFill>
                   <a:srgbClr val="A9AFB6"/>
                 </a:solidFill>
-                <a:latin typeface="Inter"/>
+                <a:latin typeface="Calibri"/>
               </a:rPr>
               <a:t>Five interlinked tools — requests, catalogue, KPIs, vendors and agreements — rebuilt as one decision layer for Commercial Insights &amp; Data Procurement.</a:t>
             </a:r>
@@ -5417,7 +5417,7 @@
                 <a:solidFill>
                   <a:srgbClr val="A9AFB6"/>
                 </a:solidFill>
-                <a:latin typeface="Inter"/>
+                <a:latin typeface="Calibri"/>
               </a:rPr>
               <a:t>Prepared for: NovaCura Pharmaceuticals (illustrative)   ·   Working prototype walkthrough   ·   Synthetic data</a:t>
             </a:r>
@@ -5529,7 +5529,7 @@
                 <a:solidFill>
                   <a:srgbClr val="F89739"/>
                 </a:solidFill>
-                <a:latin typeface="Inter"/>
+                <a:latin typeface="Calibri"/>
               </a:rPr>
               <a:t>TOOL 1 — WORKFLOW</a:t>
             </a:r>
@@ -5571,7 +5571,7 @@
                 <a:solidFill>
                   <a:srgbClr val="09131B"/>
                 </a:solidFill>
-                <a:latin typeface="Inter"/>
+                <a:latin typeface="Calibri"/>
               </a:rPr>
               <a:t>Data Requests (DPRH)</a:t>
             </a:r>
@@ -5613,7 +5613,7 @@
                 <a:solidFill>
                   <a:srgbClr val="595959"/>
                 </a:solidFill>
-                <a:latin typeface="Inter"/>
+                <a:latin typeface="Calibri"/>
               </a:rPr>
               <a:t>One combined, role-gated form governs every data buy before money is committed.</a:t>
             </a:r>
@@ -5749,7 +5749,7 @@
                 <a:solidFill>
                   <a:srgbClr val="09131B"/>
                 </a:solidFill>
-                <a:latin typeface="Inter"/>
+                <a:latin typeface="Calibri"/>
               </a:rPr>
               <a:t>1</a:t>
             </a:r>
@@ -5791,7 +5791,7 @@
                 <a:solidFill>
                   <a:srgbClr val="09131B"/>
                 </a:solidFill>
-                <a:latin typeface="Inter"/>
+                <a:latin typeface="Calibri"/>
               </a:rPr>
               <a:t>Role-gated approval</a:t>
             </a:r>
@@ -5810,7 +5810,7 @@
                 <a:solidFill>
                   <a:srgbClr val="595959"/>
                 </a:solidFill>
-                <a:latin typeface="Inter"/>
+                <a:latin typeface="Calibri"/>
               </a:rPr>
               <a:t>A single form raises the request; reviewers see only their section. Routes Requester → Regional + Admin → Committee → Admin final, by national/sub-national scope and cost threshold.</a:t>
             </a:r>
@@ -5946,7 +5946,7 @@
                 <a:solidFill>
                   <a:srgbClr val="09131B"/>
                 </a:solidFill>
-                <a:latin typeface="Inter"/>
+                <a:latin typeface="Calibri"/>
               </a:rPr>
               <a:t>2</a:t>
             </a:r>
@@ -5988,7 +5988,7 @@
                 <a:solidFill>
                   <a:srgbClr val="09131B"/>
                 </a:solidFill>
-                <a:latin typeface="Inter"/>
+                <a:latin typeface="Calibri"/>
               </a:rPr>
               <a:t>Automation built in</a:t>
             </a:r>
@@ -6007,7 +6007,7 @@
                 <a:solidFill>
                   <a:srgbClr val="595959"/>
                 </a:solidFill>
-                <a:latin typeface="Inter"/>
+                <a:latin typeface="Calibri"/>
               </a:rPr>
               <a:t>On renewal the form pre-fills from the catalogue; once purchased, one click writes every field back into the catalogue — no re-keying, no drift.</a:t>
             </a:r>
@@ -6143,7 +6143,7 @@
                 <a:solidFill>
                   <a:srgbClr val="09131B"/>
                 </a:solidFill>
-                <a:latin typeface="Inter"/>
+                <a:latin typeface="Calibri"/>
               </a:rPr>
               <a:t>3</a:t>
             </a:r>
@@ -6185,7 +6185,7 @@
                 <a:solidFill>
                   <a:srgbClr val="09131B"/>
                 </a:solidFill>
-                <a:latin typeface="Inter"/>
+                <a:latin typeface="Calibri"/>
               </a:rPr>
               <a:t>Duplicate-buy detection</a:t>
             </a:r>
@@ -6204,7 +6204,7 @@
                 <a:solidFill>
                   <a:srgbClr val="595959"/>
                 </a:solidFill>
-                <a:latin typeface="Inter"/>
+                <a:latin typeface="Calibri"/>
               </a:rPr>
               <a:t>At intake, Atlas matches the request against the catalogue on vendor, therapeutic area and data type — and flags overlap before spend.</a:t>
             </a:r>
@@ -6246,7 +6246,7 @@
                 <a:solidFill>
                   <a:srgbClr val="F89739"/>
                 </a:solidFill>
-                <a:latin typeface="Inter"/>
+                <a:latin typeface="Calibri"/>
               </a:rPr>
               <a:t>WHAT THE PROTOTYPE SURFACES</a:t>
             </a:r>
@@ -6288,7 +6288,7 @@
                 <a:solidFill>
                   <a:srgbClr val="09131B"/>
                 </a:solidFill>
-                <a:latin typeface="Inter"/>
+                <a:latin typeface="Calibri"/>
               </a:rPr>
               <a:t>2 in-flight requests flagged as overlapping data already owned — roughly $1.09M of exposure to review before approval.</a:t>
             </a:r>
@@ -6330,7 +6330,7 @@
                 <a:solidFill>
                   <a:srgbClr val="595959"/>
                 </a:solidFill>
-                <a:latin typeface="Inter"/>
+                <a:latin typeface="Calibri"/>
               </a:rPr>
               <a:t>Production feeds:</a:t>
             </a:r>
@@ -6420,7 +6420,7 @@
                 <a:solidFill>
                   <a:srgbClr val="595959"/>
                 </a:solidFill>
-                <a:latin typeface="Inter"/>
+                <a:latin typeface="Calibri"/>
               </a:rPr>
               <a:t>SharePoint</a:t>
             </a:r>
@@ -6510,7 +6510,7 @@
                 <a:solidFill>
                   <a:srgbClr val="595959"/>
                 </a:solidFill>
-                <a:latin typeface="Inter"/>
+                <a:latin typeface="Calibri"/>
               </a:rPr>
               <a:t>Power Automate</a:t>
             </a:r>
@@ -6600,7 +6600,7 @@
                 <a:solidFill>
                   <a:srgbClr val="595959"/>
                 </a:solidFill>
-                <a:latin typeface="Inter"/>
+                <a:latin typeface="Calibri"/>
               </a:rPr>
               <a:t>Veeva CRM</a:t>
             </a:r>
@@ -6686,7 +6686,7 @@
                 <a:solidFill>
                   <a:srgbClr val="A9AFB6"/>
                 </a:solidFill>
-                <a:latin typeface="Inter"/>
+                <a:latin typeface="Calibri"/>
               </a:rPr>
               <a:t>Cortex Atlas  ·  Illustrative prototype, synthetic data  ·  Confidential</a:t>
             </a:r>
@@ -6728,7 +6728,7 @@
                 <a:solidFill>
                   <a:srgbClr val="A9AFB6"/>
                 </a:solidFill>
-                <a:latin typeface="Inter"/>
+                <a:latin typeface="Calibri"/>
               </a:rPr>
               <a:t>6</a:t>
             </a:r>
@@ -6840,7 +6840,7 @@
                 <a:solidFill>
                   <a:srgbClr val="F89739"/>
                 </a:solidFill>
-                <a:latin typeface="Inter"/>
+                <a:latin typeface="Calibri"/>
               </a:rPr>
               <a:t>TOOL 2 — SYSTEM OF RECORD</a:t>
             </a:r>
@@ -6882,7 +6882,7 @@
                 <a:solidFill>
                   <a:srgbClr val="09131B"/>
                 </a:solidFill>
-                <a:latin typeface="Inter"/>
+                <a:latin typeface="Calibri"/>
               </a:rPr>
               <a:t>Data Catalogue</a:t>
             </a:r>
@@ -6924,7 +6924,7 @@
                 <a:solidFill>
                   <a:srgbClr val="595959"/>
                 </a:solidFill>
-                <a:latin typeface="Inter"/>
+                <a:latin typeface="Calibri"/>
               </a:rPr>
               <a:t>The central record of every asset purchased — the single source everything links to.</a:t>
             </a:r>
@@ -7060,7 +7060,7 @@
                 <a:solidFill>
                   <a:srgbClr val="09131B"/>
                 </a:solidFill>
-                <a:latin typeface="Inter"/>
+                <a:latin typeface="Calibri"/>
               </a:rPr>
               <a:t>1</a:t>
             </a:r>
@@ -7102,7 +7102,7 @@
                 <a:solidFill>
                   <a:srgbClr val="09131B"/>
                 </a:solidFill>
-                <a:latin typeface="Inter"/>
+                <a:latin typeface="Calibri"/>
               </a:rPr>
               <a:t>One rich record</a:t>
             </a:r>
@@ -7121,7 +7121,7 @@
                 <a:solidFill>
                   <a:srgbClr val="595959"/>
                 </a:solidFill>
-                <a:latin typeface="Inter"/>
+                <a:latin typeface="Calibri"/>
               </a:rPr>
               <a:t>The full asset profile — identity, classification, coverage, quality, commercials, access — with Gold / Silver / Bronze quality and PII / PHI flags.</a:t>
             </a:r>
@@ -7257,7 +7257,7 @@
                 <a:solidFill>
                   <a:srgbClr val="09131B"/>
                 </a:solidFill>
-                <a:latin typeface="Inter"/>
+                <a:latin typeface="Calibri"/>
               </a:rPr>
               <a:t>2</a:t>
             </a:r>
@@ -7299,7 +7299,7 @@
                 <a:solidFill>
                   <a:srgbClr val="09131B"/>
                 </a:solidFill>
-                <a:latin typeface="Inter"/>
+                <a:latin typeface="Calibri"/>
               </a:rPr>
               <a:t>Auto-classification</a:t>
             </a:r>
@@ -7318,7 +7318,7 @@
                 <a:solidFill>
                   <a:srgbClr val="595959"/>
                 </a:solidFill>
-                <a:latin typeface="Inter"/>
+                <a:latin typeface="Calibri"/>
               </a:rPr>
               <a:t>On a new entry, granularity and archetype drive automatic PII/PHI detection and a suggested quality tier — governance by default, not by afterthought.</a:t>
             </a:r>
@@ -7454,7 +7454,7 @@
                 <a:solidFill>
                   <a:srgbClr val="09131B"/>
                 </a:solidFill>
-                <a:latin typeface="Inter"/>
+                <a:latin typeface="Calibri"/>
               </a:rPr>
               <a:t>3</a:t>
             </a:r>
@@ -7496,7 +7496,7 @@
                 <a:solidFill>
                   <a:srgbClr val="09131B"/>
                 </a:solidFill>
-                <a:latin typeface="Inter"/>
+                <a:latin typeface="Calibri"/>
               </a:rPr>
               <a:t>Three ways in</a:t>
             </a:r>
@@ -7515,7 +7515,7 @@
                 <a:solidFill>
                   <a:srgbClr val="595959"/>
                 </a:solidFill>
-                <a:latin typeface="Inter"/>
+                <a:latin typeface="Calibri"/>
               </a:rPr>
               <a:t>An approved request, a renewal read-back, or a manual entry — all land in the same trusted record. 'Do we already own this?' finally has one answer.</a:t>
             </a:r>
@@ -7557,7 +7557,7 @@
                 <a:solidFill>
                   <a:srgbClr val="F89739"/>
                 </a:solidFill>
-                <a:latin typeface="Inter"/>
+                <a:latin typeface="Calibri"/>
               </a:rPr>
               <a:t>WHAT THE PROTOTYPE SURFACES</a:t>
             </a:r>
@@ -7599,7 +7599,7 @@
                 <a:solidFill>
                   <a:srgbClr val="09131B"/>
                 </a:solidFill>
-                <a:latin typeface="Inter"/>
+                <a:latin typeface="Calibri"/>
               </a:rPr>
               <a:t>A Bronze-tier asset is feeding a Global, strategic KPI — surfaced as a quality flag before the number is used externally.</a:t>
             </a:r>
@@ -7641,7 +7641,7 @@
                 <a:solidFill>
                   <a:srgbClr val="595959"/>
                 </a:solidFill>
-                <a:latin typeface="Inter"/>
+                <a:latin typeface="Calibri"/>
               </a:rPr>
               <a:t>Production feeds:</a:t>
             </a:r>
@@ -7731,7 +7731,7 @@
                 <a:solidFill>
                   <a:srgbClr val="595959"/>
                 </a:solidFill>
-                <a:latin typeface="Inter"/>
+                <a:latin typeface="Calibri"/>
               </a:rPr>
               <a:t>SharePoint</a:t>
             </a:r>
@@ -7821,7 +7821,7 @@
                 <a:solidFill>
                   <a:srgbClr val="595959"/>
                 </a:solidFill>
-                <a:latin typeface="Inter"/>
+                <a:latin typeface="Calibri"/>
               </a:rPr>
               <a:t>Microsoft Purview</a:t>
             </a:r>
@@ -7911,7 +7911,7 @@
                 <a:solidFill>
                   <a:srgbClr val="595959"/>
                 </a:solidFill>
-                <a:latin typeface="Inter"/>
+                <a:latin typeface="Calibri"/>
               </a:rPr>
               <a:t>Databricks</a:t>
             </a:r>
@@ -8001,7 +8001,7 @@
                 <a:solidFill>
                   <a:srgbClr val="595959"/>
                 </a:solidFill>
-                <a:latin typeface="Inter"/>
+                <a:latin typeface="Calibri"/>
               </a:rPr>
               <a:t>Model N</a:t>
             </a:r>
@@ -8087,7 +8087,7 @@
                 <a:solidFill>
                   <a:srgbClr val="A9AFB6"/>
                 </a:solidFill>
-                <a:latin typeface="Inter"/>
+                <a:latin typeface="Calibri"/>
               </a:rPr>
               <a:t>Cortex Atlas  ·  Illustrative prototype, synthetic data  ·  Confidential</a:t>
             </a:r>
@@ -8129,7 +8129,7 @@
                 <a:solidFill>
                   <a:srgbClr val="A9AFB6"/>
                 </a:solidFill>
-                <a:latin typeface="Inter"/>
+                <a:latin typeface="Calibri"/>
               </a:rPr>
               <a:t>7</a:t>
             </a:r>
@@ -8241,7 +8241,7 @@
                 <a:solidFill>
                   <a:srgbClr val="F89739"/>
                 </a:solidFill>
-                <a:latin typeface="Inter"/>
+                <a:latin typeface="Calibri"/>
               </a:rPr>
               <a:t>TOOL 3 — LINEAGE</a:t>
             </a:r>
@@ -8283,7 +8283,7 @@
                 <a:solidFill>
                   <a:srgbClr val="09131B"/>
                 </a:solidFill>
-                <a:latin typeface="Inter"/>
+                <a:latin typeface="Calibri"/>
               </a:rPr>
               <a:t>KPI Catalogue</a:t>
             </a:r>
@@ -8325,7 +8325,7 @@
                 <a:solidFill>
                   <a:srgbClr val="595959"/>
                 </a:solidFill>
-                <a:latin typeface="Inter"/>
+                <a:latin typeface="Calibri"/>
               </a:rPr>
               <a:t>The registry of metrics built on the data — each tied back to its source.</a:t>
             </a:r>
@@ -8461,7 +8461,7 @@
                 <a:solidFill>
                   <a:srgbClr val="09131B"/>
                 </a:solidFill>
-                <a:latin typeface="Inter"/>
+                <a:latin typeface="Calibri"/>
               </a:rPr>
               <a:t>1</a:t>
             </a:r>
@@ -8503,7 +8503,7 @@
                 <a:solidFill>
                   <a:srgbClr val="09131B"/>
                 </a:solidFill>
-                <a:latin typeface="Inter"/>
+                <a:latin typeface="Calibri"/>
               </a:rPr>
               <a:t>Full KPI metadata</a:t>
             </a:r>
@@ -8522,7 +8522,7 @@
                 <a:solidFill>
                   <a:srgbClr val="595959"/>
                 </a:solidFill>
-                <a:latin typeface="Inter"/>
+                <a:latin typeface="Calibri"/>
               </a:rPr>
               <a:t>Definition, methodology, market definition, cadence, deliverables and contacts — the institutional memory of every metric, in one place.</a:t>
             </a:r>
@@ -8658,7 +8658,7 @@
                 <a:solidFill>
                   <a:srgbClr val="09131B"/>
                 </a:solidFill>
-                <a:latin typeface="Inter"/>
+                <a:latin typeface="Calibri"/>
               </a:rPr>
               <a:t>2</a:t>
             </a:r>
@@ -8700,7 +8700,7 @@
                 <a:solidFill>
                   <a:srgbClr val="09131B"/>
                 </a:solidFill>
-                <a:latin typeface="Inter"/>
+                <a:latin typeface="Calibri"/>
               </a:rPr>
               <a:t>Lineage to source</a:t>
             </a:r>
@@ -8719,7 +8719,7 @@
                 <a:solidFill>
                   <a:srgbClr val="595959"/>
                 </a:solidFill>
-                <a:latin typeface="Inter"/>
+                <a:latin typeface="Calibri"/>
               </a:rPr>
               <a:t>Every KPI links to the catalogue asset (and therefore the vendor) that feeds it — so you can trace any number to its origin.</a:t>
             </a:r>
@@ -8855,7 +8855,7 @@
                 <a:solidFill>
                   <a:srgbClr val="09131B"/>
                 </a:solidFill>
-                <a:latin typeface="Inter"/>
+                <a:latin typeface="Calibri"/>
               </a:rPr>
               <a:t>3</a:t>
             </a:r>
@@ -8897,7 +8897,7 @@
                 <a:solidFill>
                   <a:srgbClr val="09131B"/>
                 </a:solidFill>
-                <a:latin typeface="Inter"/>
+                <a:latin typeface="Calibri"/>
               </a:rPr>
               <a:t>Quality risk, visible</a:t>
             </a:r>
@@ -8916,7 +8916,7 @@
                 <a:solidFill>
                   <a:srgbClr val="595959"/>
                 </a:solidFill>
-                <a:latin typeface="Inter"/>
+                <a:latin typeface="Calibri"/>
               </a:rPr>
               <a:t>When a strategic KPI rests on a low-tier asset, Atlas flags it — you learn how trustworthy a metric is, not just what it says.</a:t>
             </a:r>
@@ -8958,7 +8958,7 @@
                 <a:solidFill>
                   <a:srgbClr val="F89739"/>
                 </a:solidFill>
-                <a:latin typeface="Inter"/>
+                <a:latin typeface="Calibri"/>
               </a:rPr>
               <a:t>WHAT THE PROTOTYPE SURFACES</a:t>
             </a:r>
@@ -9000,7 +9000,7 @@
                 <a:solidFill>
                   <a:srgbClr val="09131B"/>
                 </a:solidFill>
-                <a:latin typeface="Inter"/>
+                <a:latin typeface="Calibri"/>
               </a:rPr>
               <a:t>Trace 'Diagnosed-but-Untreated Funnel' in two clicks: KPI → Bronze registry asset → vendor Quanta — with the quality caveat attached.</a:t>
             </a:r>
@@ -9042,7 +9042,7 @@
                 <a:solidFill>
                   <a:srgbClr val="595959"/>
                 </a:solidFill>
-                <a:latin typeface="Inter"/>
+                <a:latin typeface="Calibri"/>
               </a:rPr>
               <a:t>Production feeds:</a:t>
             </a:r>
@@ -9132,7 +9132,7 @@
                 <a:solidFill>
                   <a:srgbClr val="595959"/>
                 </a:solidFill>
-                <a:latin typeface="Inter"/>
+                <a:latin typeface="Calibri"/>
               </a:rPr>
               <a:t>SharePoint</a:t>
             </a:r>
@@ -9222,7 +9222,7 @@
                 <a:solidFill>
                   <a:srgbClr val="595959"/>
                 </a:solidFill>
-                <a:latin typeface="Inter"/>
+                <a:latin typeface="Calibri"/>
               </a:rPr>
               <a:t>KPI Catalogue</a:t>
             </a:r>
@@ -9312,7 +9312,7 @@
                 <a:solidFill>
                   <a:srgbClr val="595959"/>
                 </a:solidFill>
-                <a:latin typeface="Inter"/>
+                <a:latin typeface="Calibri"/>
               </a:rPr>
               <a:t>Microsoft Purview</a:t>
             </a:r>
@@ -9398,7 +9398,7 @@
                 <a:solidFill>
                   <a:srgbClr val="A9AFB6"/>
                 </a:solidFill>
-                <a:latin typeface="Inter"/>
+                <a:latin typeface="Calibri"/>
               </a:rPr>
               <a:t>Cortex Atlas  ·  Illustrative prototype, synthetic data  ·  Confidential</a:t>
             </a:r>
@@ -9440,7 +9440,7 @@
                 <a:solidFill>
                   <a:srgbClr val="A9AFB6"/>
                 </a:solidFill>
-                <a:latin typeface="Inter"/>
+                <a:latin typeface="Calibri"/>
               </a:rPr>
               <a:t>8</a:t>
             </a:r>
@@ -9552,7 +9552,7 @@
                 <a:solidFill>
                   <a:srgbClr val="F89739"/>
                 </a:solidFill>
-                <a:latin typeface="Inter"/>
+                <a:latin typeface="Calibri"/>
               </a:rPr>
               <a:t>TOOL 4 — INVENTORY</a:t>
             </a:r>
@@ -9594,7 +9594,7 @@
                 <a:solidFill>
                   <a:srgbClr val="09131B"/>
                 </a:solidFill>
-                <a:latin typeface="Inter"/>
+                <a:latin typeface="Calibri"/>
               </a:rPr>
               <a:t>Vendor Hub</a:t>
             </a:r>
@@ -9636,7 +9636,7 @@
                 <a:solidFill>
                   <a:srgbClr val="595959"/>
                 </a:solidFill>
-                <a:latin typeface="Inter"/>
+                <a:latin typeface="Calibri"/>
               </a:rPr>
               <a:t>The vendor-centric view: who they are, what they hold, and what we actually buy.</a:t>
             </a:r>
@@ -9772,7 +9772,7 @@
                 <a:solidFill>
                   <a:srgbClr val="09131B"/>
                 </a:solidFill>
-                <a:latin typeface="Inter"/>
+                <a:latin typeface="Calibri"/>
               </a:rPr>
               <a:t>1</a:t>
             </a:r>
@@ -9814,7 +9814,7 @@
                 <a:solidFill>
                   <a:srgbClr val="09131B"/>
                 </a:solidFill>
-                <a:latin typeface="Inter"/>
+                <a:latin typeface="Calibri"/>
               </a:rPr>
               <a:t>Vendor inventory</a:t>
             </a:r>
@@ -9833,7 +9833,7 @@
                 <a:solidFill>
                   <a:srgbClr val="595959"/>
                 </a:solidFill>
-                <a:latin typeface="Inter"/>
+                <a:latin typeface="Calibri"/>
               </a:rPr>
               <a:t>Each vendor as a first-class record — the data they offer, how to access it, contacts and guidance, in one place.</a:t>
             </a:r>
@@ -9969,7 +9969,7 @@
                 <a:solidFill>
                   <a:srgbClr val="09131B"/>
                 </a:solidFill>
-                <a:latin typeface="Inter"/>
+                <a:latin typeface="Calibri"/>
               </a:rPr>
               <a:t>2</a:t>
             </a:r>
@@ -10011,7 +10011,7 @@
                 <a:solidFill>
                   <a:srgbClr val="09131B"/>
                 </a:solidFill>
-                <a:latin typeface="Inter"/>
+                <a:latin typeface="Calibri"/>
               </a:rPr>
               <a:t>Purchased vs available</a:t>
             </a:r>
@@ -10030,7 +10030,7 @@
                 <a:solidFill>
                   <a:srgbClr val="595959"/>
                 </a:solidFill>
-                <a:latin typeface="Inter"/>
+                <a:latin typeface="Calibri"/>
               </a:rPr>
               <a:t>For every vendor, what we buy versus everything they offer — turning coverage into a negotiating fact.</a:t>
             </a:r>
@@ -10166,7 +10166,7 @@
                 <a:solidFill>
                   <a:srgbClr val="09131B"/>
                 </a:solidFill>
-                <a:latin typeface="Inter"/>
+                <a:latin typeface="Calibri"/>
               </a:rPr>
               <a:t>3</a:t>
             </a:r>
@@ -10208,7 +10208,7 @@
                 <a:solidFill>
                   <a:srgbClr val="09131B"/>
                 </a:solidFill>
-                <a:latin typeface="Inter"/>
+                <a:latin typeface="Calibri"/>
               </a:rPr>
               <a:t>Built to roll up</a:t>
             </a:r>
@@ -10227,7 +10227,7 @@
                 <a:solidFill>
                   <a:srgbClr val="595959"/>
                 </a:solidFill>
-                <a:latin typeface="Inter"/>
+                <a:latin typeface="Calibri"/>
               </a:rPr>
               <a:t>Assets link up to the vendor, so quality, spend and dependency aggregate cleanly — the foundation for the value layer next.</a:t>
             </a:r>
@@ -10269,7 +10269,7 @@
                 <a:solidFill>
                   <a:srgbClr val="F89739"/>
                 </a:solidFill>
-                <a:latin typeface="Inter"/>
+                <a:latin typeface="Calibri"/>
               </a:rPr>
               <a:t>WHAT THE PROTOTYPE SURFACES</a:t>
             </a:r>
@@ -10311,7 +10311,7 @@
                 <a:solidFill>
                   <a:srgbClr val="09131B"/>
                 </a:solidFill>
-                <a:latin typeface="Inter"/>
+                <a:latin typeface="Calibri"/>
               </a:rPr>
               <a:t>8 vendors supplying 12 assets — and a clear read on how much of each vendor's catalogue we've actually licensed.</a:t>
             </a:r>
@@ -10353,7 +10353,7 @@
                 <a:solidFill>
                   <a:srgbClr val="595959"/>
                 </a:solidFill>
-                <a:latin typeface="Inter"/>
+                <a:latin typeface="Calibri"/>
               </a:rPr>
               <a:t>Production feeds:</a:t>
             </a:r>
@@ -10443,7 +10443,7 @@
                 <a:solidFill>
                   <a:srgbClr val="595959"/>
                 </a:solidFill>
-                <a:latin typeface="Inter"/>
+                <a:latin typeface="Calibri"/>
               </a:rPr>
               <a:t>SharePoint</a:t>
             </a:r>
@@ -10533,7 +10533,7 @@
                 <a:solidFill>
                   <a:srgbClr val="595959"/>
                 </a:solidFill>
-                <a:latin typeface="Inter"/>
+                <a:latin typeface="Calibri"/>
               </a:rPr>
               <a:t>Vendor Hub</a:t>
             </a:r>
@@ -10623,7 +10623,7 @@
                 <a:solidFill>
                   <a:srgbClr val="595959"/>
                 </a:solidFill>
-                <a:latin typeface="Inter"/>
+                <a:latin typeface="Calibri"/>
               </a:rPr>
               <a:t>Veeva CRM</a:t>
             </a:r>
@@ -10709,7 +10709,7 @@
                 <a:solidFill>
                   <a:srgbClr val="A9AFB6"/>
                 </a:solidFill>
-                <a:latin typeface="Inter"/>
+                <a:latin typeface="Calibri"/>
               </a:rPr>
               <a:t>Cortex Atlas  ·  Illustrative prototype, synthetic data  ·  Confidential</a:t>
             </a:r>
@@ -10751,7 +10751,7 @@
                 <a:solidFill>
                   <a:srgbClr val="A9AFB6"/>
                 </a:solidFill>
-                <a:latin typeface="Inter"/>
+                <a:latin typeface="Calibri"/>
               </a:rPr>
               <a:t>9</a:t>
             </a:r>
@@ -10863,7 +10863,7 @@
                 <a:solidFill>
                   <a:srgbClr val="F89739"/>
                 </a:solidFill>
-                <a:latin typeface="Inter"/>
+                <a:latin typeface="Calibri"/>
               </a:rPr>
               <a:t>INTELLIGENCE — THE DIFFERENTIATOR</a:t>
             </a:r>
@@ -10905,7 +10905,7 @@
                 <a:solidFill>
                   <a:srgbClr val="FFFFFF"/>
                 </a:solidFill>
-                <a:latin typeface="Inter"/>
+                <a:latin typeface="Calibri"/>
               </a:rPr>
               <a:t>Vendor Hub Plus — the value layer</a:t>
             </a:r>
@@ -10947,7 +10947,7 @@
                 <a:solidFill>
                   <a:srgbClr val="A9AFB6"/>
                 </a:solidFill>
-                <a:latin typeface="Inter"/>
+                <a:latin typeface="Calibri"/>
               </a:rPr>
               <a:t>The same inventory, rolled up into the five things a vendor decision actually needs.</a:t>
             </a:r>
@@ -11083,7 +11083,7 @@
                 <a:solidFill>
                   <a:srgbClr val="09131B"/>
                 </a:solidFill>
-                <a:latin typeface="Inter"/>
+                <a:latin typeface="Calibri"/>
               </a:rPr>
               <a:t>1</a:t>
             </a:r>
@@ -11125,7 +11125,7 @@
                 <a:solidFill>
                   <a:srgbClr val="FFFFFF"/>
                 </a:solidFill>
-                <a:latin typeface="Inter"/>
+                <a:latin typeface="Calibri"/>
               </a:rPr>
               <a:t>Quality score</a:t>
             </a:r>
@@ -11144,7 +11144,7 @@
                 <a:solidFill>
                   <a:srgbClr val="C7CCD3"/>
                 </a:solidFill>
-                <a:latin typeface="Inter"/>
+                <a:latin typeface="Calibri"/>
               </a:rPr>
               <a:t>Asset-level Gold/Silver/Bronze rolled up to a composite vendor grade — who delivers quality, not just who exists.</a:t>
             </a:r>
@@ -11280,7 +11280,7 @@
                 <a:solidFill>
                   <a:srgbClr val="09131B"/>
                 </a:solidFill>
-                <a:latin typeface="Inter"/>
+                <a:latin typeface="Calibri"/>
               </a:rPr>
               <a:t>2</a:t>
             </a:r>
@@ -11322,7 +11322,7 @@
                 <a:solidFill>
                   <a:srgbClr val="FFFFFF"/>
                 </a:solidFill>
-                <a:latin typeface="Inter"/>
+                <a:latin typeface="Calibri"/>
               </a:rPr>
               <a:t>Spend concentration</a:t>
             </a:r>
@@ -11341,7 +11341,7 @@
                 <a:solidFill>
                   <a:srgbClr val="C7CCD3"/>
                 </a:solidFill>
-                <a:latin typeface="Inter"/>
+                <a:latin typeface="Calibri"/>
               </a:rPr>
               <a:t>Each vendor's share of spend, with an estate-wide HHI — single-vendor dependency made measurable.</a:t>
             </a:r>
@@ -11477,7 +11477,7 @@
                 <a:solidFill>
                   <a:srgbClr val="09131B"/>
                 </a:solidFill>
-                <a:latin typeface="Inter"/>
+                <a:latin typeface="Calibri"/>
               </a:rPr>
               <a:t>3</a:t>
             </a:r>
@@ -11519,7 +11519,7 @@
                 <a:solidFill>
                   <a:srgbClr val="FFFFFF"/>
                 </a:solidFill>
-                <a:latin typeface="Inter"/>
+                <a:latin typeface="Calibri"/>
               </a:rPr>
               <a:t>Irreplaceability</a:t>
             </a:r>
@@ -11538,7 +11538,7 @@
                 <a:solidFill>
                   <a:srgbClr val="C7CCD3"/>
                 </a:solidFill>
-                <a:latin typeface="Inter"/>
+                <a:latin typeface="Calibri"/>
               </a:rPr>
               <a:t>What breaks if a vendor walks: assets and downstream KPIs at stake versus available substitutes.</a:t>
             </a:r>
@@ -11674,7 +11674,7 @@
                 <a:solidFill>
                   <a:srgbClr val="09131B"/>
                 </a:solidFill>
-                <a:latin typeface="Inter"/>
+                <a:latin typeface="Calibri"/>
               </a:rPr>
               <a:t>4</a:t>
             </a:r>
@@ -11716,7 +11716,7 @@
                 <a:solidFill>
                   <a:srgbClr val="FFFFFF"/>
                 </a:solidFill>
-                <a:latin typeface="Inter"/>
+                <a:latin typeface="Calibri"/>
               </a:rPr>
               <a:t>Cost-per-quality</a:t>
             </a:r>
@@ -11735,7 +11735,7 @@
                 <a:solidFill>
                   <a:srgbClr val="C7CCD3"/>
                 </a:solidFill>
-                <a:latin typeface="Inter"/>
+                <a:latin typeface="Calibri"/>
               </a:rPr>
               <a:t>Spend normalised against quality — are we overpaying for low-tier data? Renegotiation candidates surface.</a:t>
             </a:r>
@@ -11871,7 +11871,7 @@
                 <a:solidFill>
                   <a:srgbClr val="09131B"/>
                 </a:solidFill>
-                <a:latin typeface="Inter"/>
+                <a:latin typeface="Calibri"/>
               </a:rPr>
               <a:t>5</a:t>
             </a:r>
@@ -11913,7 +11913,7 @@
                 <a:solidFill>
                   <a:srgbClr val="FFFFFF"/>
                 </a:solidFill>
-                <a:latin typeface="Inter"/>
+                <a:latin typeface="Calibri"/>
               </a:rPr>
               <a:t>Leverage</a:t>
             </a:r>
@@ -11932,7 +11932,7 @@
                 <a:solidFill>
                   <a:srgbClr val="C7CCD3"/>
                 </a:solidFill>
-                <a:latin typeface="Inter"/>
+                <a:latin typeface="Calibri"/>
               </a:rPr>
               <a:t>Purchased vs available becomes a negotiation lever — coverage gaps as consolidation opportunities.</a:t>
             </a:r>
@@ -11974,7 +11974,7 @@
                 <a:solidFill>
                   <a:srgbClr val="F89739"/>
                 </a:solidFill>
-                <a:latin typeface="Inter"/>
+                <a:latin typeface="Calibri"/>
               </a:rPr>
               <a:t>Prototype reads: HHI ≈ 1,825 (moderate) · top two vendors hold ~50% of spend · cost-per-quality outlier flagged for renegotiation.</a:t>
             </a:r>
@@ -11993,7 +11993,7 @@
                 <a:solidFill>
                   <a:srgbClr val="A9AFB6"/>
                 </a:solidFill>
-                <a:latin typeface="Inter"/>
+                <a:latin typeface="Calibri"/>
               </a:rPr>
               <a:t>All advisory — it informs the vendor and renewal decision; a human makes the call.</a:t>
             </a:r>
@@ -12079,7 +12079,7 @@
                 <a:solidFill>
                   <a:srgbClr val="A9AFB6"/>
                 </a:solidFill>
-                <a:latin typeface="Inter"/>
+                <a:latin typeface="Calibri"/>
               </a:rPr>
               <a:t>Cortex Atlas  ·  Illustrative prototype, synthetic data  ·  Confidential</a:t>
             </a:r>
@@ -12121,7 +12121,7 @@
                 <a:solidFill>
                   <a:srgbClr val="A9AFB6"/>
                 </a:solidFill>
-                <a:latin typeface="Inter"/>
+                <a:latin typeface="Calibri"/>
               </a:rPr>
               <a:t>10</a:t>
             </a:r>
@@ -12233,7 +12233,7 @@
                 <a:solidFill>
                   <a:srgbClr val="F89739"/>
                 </a:solidFill>
-                <a:latin typeface="Inter"/>
+                <a:latin typeface="Calibri"/>
               </a:rPr>
               <a:t>TOOL 5 — CONTINUOUS CONTROL</a:t>
             </a:r>
@@ -12275,7 +12275,7 @@
                 <a:solidFill>
                   <a:srgbClr val="09131B"/>
                 </a:solidFill>
-                <a:latin typeface="Inter"/>
+                <a:latin typeface="Calibri"/>
               </a:rPr>
               <a:t>TPA Hub</a:t>
             </a:r>
@@ -12317,7 +12317,7 @@
                 <a:solidFill>
                   <a:srgbClr val="595959"/>
                 </a:solidFill>
-                <a:latin typeface="Inter"/>
+                <a:latin typeface="Calibri"/>
               </a:rPr>
               <a:t>The agreement register — and an active reminder engine that already runs.</a:t>
             </a:r>
@@ -12453,7 +12453,7 @@
                 <a:solidFill>
                   <a:srgbClr val="09131B"/>
                 </a:solidFill>
-                <a:latin typeface="Inter"/>
+                <a:latin typeface="Calibri"/>
               </a:rPr>
               <a:t>1</a:t>
             </a:r>
@@ -12495,7 +12495,7 @@
                 <a:solidFill>
                   <a:srgbClr val="09131B"/>
                 </a:solidFill>
-                <a:latin typeface="Inter"/>
+                <a:latin typeface="Calibri"/>
               </a:rPr>
               <a:t>30/60/90 reminders</a:t>
             </a:r>
@@ -12514,7 +12514,7 @@
                 <a:solidFill>
                   <a:srgbClr val="595959"/>
                 </a:solidFill>
-                <a:latin typeface="Inter"/>
+                <a:latin typeface="Calibri"/>
               </a:rPr>
               <a:t>Every agreement is tracked to expiry; reminders fire automatically at 90, 60 and 30 days, escalating to the owner inside 30.</a:t>
             </a:r>
@@ -12650,7 +12650,7 @@
                 <a:solidFill>
                   <a:srgbClr val="09131B"/>
                 </a:solidFill>
-                <a:latin typeface="Inter"/>
+                <a:latin typeface="Calibri"/>
               </a:rPr>
               <a:t>2</a:t>
             </a:r>
@@ -12692,7 +12692,7 @@
                 <a:solidFill>
                   <a:srgbClr val="09131B"/>
                 </a:solidFill>
-                <a:latin typeface="Inter"/>
+                <a:latin typeface="Calibri"/>
               </a:rPr>
               <a:t>Runway at a glance</a:t>
             </a:r>
@@ -12711,7 +12711,7 @@
                 <a:solidFill>
                   <a:srgbClr val="595959"/>
                 </a:solidFill>
-                <a:latin typeface="Inter"/>
+                <a:latin typeface="Calibri"/>
               </a:rPr>
               <a:t>A live view of what's expiring when — moving renewals from reactive scramble to planned, leverage-preserving negotiation.</a:t>
             </a:r>
@@ -12847,7 +12847,7 @@
                 <a:solidFill>
                   <a:srgbClr val="09131B"/>
                 </a:solidFill>
-                <a:latin typeface="Inter"/>
+                <a:latin typeface="Calibri"/>
               </a:rPr>
               <a:t>3</a:t>
             </a:r>
@@ -12889,7 +12889,7 @@
                 <a:solidFill>
                   <a:srgbClr val="09131B"/>
                 </a:solidFill>
-                <a:latin typeface="Inter"/>
+                <a:latin typeface="Calibri"/>
               </a:rPr>
               <a:t>Cross-tool warning</a:t>
             </a:r>
@@ -12908,7 +12908,7 @@
                 <a:solidFill>
                   <a:srgbClr val="595959"/>
                 </a:solidFill>
-                <a:latin typeface="Inter"/>
+                <a:latin typeface="Calibri"/>
               </a:rPr>
               <a:t>Atlas connects expiry to impact: it flags when an expiring agreement sits behind a strategic KPI, and predicts renew vs retire.</a:t>
             </a:r>
@@ -12950,7 +12950,7 @@
                 <a:solidFill>
                   <a:srgbClr val="F89739"/>
                 </a:solidFill>
-                <a:latin typeface="Inter"/>
+                <a:latin typeface="Calibri"/>
               </a:rPr>
               <a:t>WHAT THE PROTOTYPE SURFACES</a:t>
             </a:r>
@@ -12992,7 +12992,7 @@
                 <a:solidFill>
                   <a:srgbClr val="09131B"/>
                 </a:solidFill>
-                <a:latin typeface="Inter"/>
+                <a:latin typeface="Calibri"/>
               </a:rPr>
               <a:t>6 agreements expire within 90 days (3 within 30) — including the sole agreement behind a Tier-1 OncoNova KPI, due in ~3 weeks.</a:t>
             </a:r>
@@ -13034,7 +13034,7 @@
                 <a:solidFill>
                   <a:srgbClr val="595959"/>
                 </a:solidFill>
-                <a:latin typeface="Inter"/>
+                <a:latin typeface="Calibri"/>
               </a:rPr>
               <a:t>Production feeds:</a:t>
             </a:r>
@@ -13124,7 +13124,7 @@
                 <a:solidFill>
                   <a:srgbClr val="595959"/>
                 </a:solidFill>
-                <a:latin typeface="Inter"/>
+                <a:latin typeface="Calibri"/>
               </a:rPr>
               <a:t>SharePoint</a:t>
             </a:r>
@@ -13214,7 +13214,7 @@
                 <a:solidFill>
                   <a:srgbClr val="595959"/>
                 </a:solidFill>
-                <a:latin typeface="Inter"/>
+                <a:latin typeface="Calibri"/>
               </a:rPr>
               <a:t>Power Automate</a:t>
             </a:r>
@@ -13304,7 +13304,7 @@
                 <a:solidFill>
                   <a:srgbClr val="595959"/>
                 </a:solidFill>
-                <a:latin typeface="Inter"/>
+                <a:latin typeface="Calibri"/>
               </a:rPr>
               <a:t>Microsoft Purview</a:t>
             </a:r>
@@ -13390,7 +13390,7 @@
                 <a:solidFill>
                   <a:srgbClr val="A9AFB6"/>
                 </a:solidFill>
-                <a:latin typeface="Inter"/>
+                <a:latin typeface="Calibri"/>
               </a:rPr>
               <a:t>Cortex Atlas  ·  Illustrative prototype, synthetic data  ·  Confidential</a:t>
             </a:r>
@@ -13432,7 +13432,7 @@
                 <a:solidFill>
                   <a:srgbClr val="A9AFB6"/>
                 </a:solidFill>
-                <a:latin typeface="Inter"/>
+                <a:latin typeface="Calibri"/>
               </a:rPr>
               <a:t>11</a:t>
             </a:r>
@@ -13544,7 +13544,7 @@
                 <a:solidFill>
                   <a:srgbClr val="F89739"/>
                 </a:solidFill>
-                <a:latin typeface="Inter"/>
+                <a:latin typeface="Calibri"/>
               </a:rPr>
               <a:t>THE DECISION LAYER</a:t>
             </a:r>
@@ -13586,7 +13586,7 @@
                 <a:solidFill>
                   <a:srgbClr val="09131B"/>
                 </a:solidFill>
-                <a:latin typeface="Inter"/>
+                <a:latin typeface="Calibri"/>
               </a:rPr>
               <a:t>Cross-tool intelligence and a natural-language ask</a:t>
             </a:r>
@@ -13676,7 +13676,7 @@
                 <a:solidFill>
                   <a:srgbClr val="09131B"/>
                 </a:solidFill>
-                <a:latin typeface="Inter"/>
+                <a:latin typeface="Calibri"/>
               </a:rPr>
               <a:t>Cross-tool signals — ranked by what's at stake</a:t>
             </a:r>
@@ -13764,7 +13764,7 @@
                 <a:solidFill>
                   <a:srgbClr val="09131B"/>
                 </a:solidFill>
-                <a:latin typeface="Inter"/>
+                <a:latin typeface="Calibri"/>
               </a:rPr>
               <a:t>Agreement at risk feeds a Tier-1 KPI</a:t>
             </a:r>
@@ -13783,7 +13783,7 @@
                 <a:solidFill>
                   <a:srgbClr val="595959"/>
                 </a:solidFill>
-                <a:latin typeface="Inter"/>
+                <a:latin typeface="Calibri"/>
               </a:rPr>
               <a:t>Helix TPA expires in ~21 days — sole source behind New-to-Brand Rx Share.</a:t>
             </a:r>
@@ -13871,7 +13871,7 @@
                 <a:solidFill>
                   <a:srgbClr val="09131B"/>
                 </a:solidFill>
-                <a:latin typeface="Inter"/>
+                <a:latin typeface="Calibri"/>
               </a:rPr>
               <a:t>Duplicate-buy risk at intake</a:t>
             </a:r>
@@ -13890,7 +13890,7 @@
                 <a:solidFill>
                   <a:srgbClr val="595959"/>
                 </a:solidFill>
-                <a:latin typeface="Inter"/>
+                <a:latin typeface="Calibri"/>
               </a:rPr>
               <a:t>DP-2042 overlaps a catalogued Oncology EMR asset — ~$640K avoidable.</a:t>
             </a:r>
@@ -13978,7 +13978,7 @@
                 <a:solidFill>
                   <a:srgbClr val="09131B"/>
                 </a:solidFill>
-                <a:latin typeface="Inter"/>
+                <a:latin typeface="Calibri"/>
               </a:rPr>
               <a:t>Low-quality asset feeds a strategic KPI</a:t>
             </a:r>
@@ -13997,7 +13997,7 @@
                 <a:solidFill>
                   <a:srgbClr val="595959"/>
                 </a:solidFill>
-                <a:latin typeface="Inter"/>
+                <a:latin typeface="Calibri"/>
               </a:rPr>
               <a:t>Bronze registry data behind the Diagnosed-but-Untreated Funnel.</a:t>
             </a:r>
@@ -14085,7 +14085,7 @@
                 <a:solidFill>
                   <a:srgbClr val="09131B"/>
                 </a:solidFill>
-                <a:latin typeface="Inter"/>
+                <a:latin typeface="Calibri"/>
               </a:rPr>
               <a:t>Vendor concentration</a:t>
             </a:r>
@@ -14104,7 +14104,7 @@
                 <a:solidFill>
                   <a:srgbClr val="595959"/>
                 </a:solidFill>
-                <a:latin typeface="Inter"/>
+                <a:latin typeface="Calibri"/>
               </a:rPr>
               <a:t>Top two vendors hold ~50% of spend; estate HHI ≈ 1,825.</a:t>
             </a:r>
@@ -14192,7 +14192,7 @@
                 <a:solidFill>
                   <a:srgbClr val="F89739"/>
                 </a:solidFill>
-                <a:latin typeface="Inter"/>
+                <a:latin typeface="Calibri"/>
               </a:rPr>
               <a:t>ASK ATLAS</a:t>
             </a:r>
@@ -14282,7 +14282,7 @@
                 <a:solidFill>
                   <a:srgbClr val="C7CCD3"/>
                 </a:solidFill>
-                <a:latin typeface="Inter"/>
+                <a:latin typeface="Calibri"/>
               </a:rPr>
               <a:t>Which agreements expire soon and feed a Tier-1 KPI?</a:t>
             </a:r>
@@ -14324,7 +14324,7 @@
                 <a:solidFill>
                   <a:srgbClr val="E8EAEE"/>
                 </a:solidFill>
-                <a:latin typeface="Inter"/>
+                <a:latin typeface="Calibri"/>
               </a:rPr>
               <a:t>Atlas answers across all five tools — grounded in the catalogue, KPI lineage, vendor spend and agreement dates — and links you straight to the record.</a:t>
             </a:r>
@@ -14343,7 +14343,7 @@
                 <a:solidFill>
                   <a:srgbClr val="A9AFB6"/>
                 </a:solidFill>
-                <a:latin typeface="Inter"/>
+                <a:latin typeface="Calibri"/>
               </a:rPr>
               <a:t>Every answer carries a confidence read and an advisory cue:</a:t>
             </a:r>
@@ -14362,7 +14362,7 @@
                 <a:solidFill>
                   <a:srgbClr val="7FD1A8"/>
                 </a:solidFill>
-                <a:latin typeface="Inter"/>
+                <a:latin typeface="Calibri"/>
               </a:rPr>
               <a:t>"Confidence: High · grounded in source rows · Advisory only — a human approves any action."</a:t>
             </a:r>
@@ -14448,7 +14448,7 @@
                 <a:solidFill>
                   <a:srgbClr val="A9AFB6"/>
                 </a:solidFill>
-                <a:latin typeface="Inter"/>
+                <a:latin typeface="Calibri"/>
               </a:rPr>
               <a:t>Cortex Atlas  ·  Illustrative prototype, synthetic data  ·  Confidential</a:t>
             </a:r>
@@ -14490,7 +14490,7 @@
                 <a:solidFill>
                   <a:srgbClr val="A9AFB6"/>
                 </a:solidFill>
-                <a:latin typeface="Inter"/>
+                <a:latin typeface="Calibri"/>
               </a:rPr>
               <a:t>12</a:t>
             </a:r>
@@ -14602,7 +14602,7 @@
                 <a:solidFill>
                   <a:srgbClr val="F89739"/>
                 </a:solidFill>
-                <a:latin typeface="Inter"/>
+                <a:latin typeface="Calibri"/>
               </a:rPr>
               <a:t>VALUE &amp; DELIVERY</a:t>
             </a:r>
@@ -14644,7 +14644,7 @@
                 <a:solidFill>
                   <a:srgbClr val="FFFFFF"/>
                 </a:solidFill>
-                <a:latin typeface="Inter"/>
+                <a:latin typeface="Calibri"/>
               </a:rPr>
               <a:t>From report to decision layer</a:t>
             </a:r>
@@ -14686,7 +14686,7 @@
                 <a:solidFill>
                   <a:srgbClr val="A9AFB6"/>
                 </a:solidFill>
-                <a:latin typeface="Inter"/>
+                <a:latin typeface="Calibri"/>
               </a:rPr>
               <a:t>What the business gets — and how we build it.</a:t>
             </a:r>
@@ -14728,7 +14728,7 @@
                 <a:solidFill>
                   <a:srgbClr val="3A4A54"/>
                 </a:solidFill>
-                <a:latin typeface="Inter"/>
+                <a:latin typeface="Calibri"/>
               </a:rPr>
               <a:t>04 / 06</a:t>
             </a:r>
@@ -14840,7 +14840,7 @@
                 <a:solidFill>
                   <a:srgbClr val="F89739"/>
                 </a:solidFill>
-                <a:latin typeface="Inter"/>
+                <a:latin typeface="Calibri"/>
               </a:rPr>
               <a:t>BUSINESS VALUE</a:t>
             </a:r>
@@ -14882,7 +14882,7 @@
                 <a:solidFill>
                   <a:srgbClr val="09131B"/>
                 </a:solidFill>
-                <a:latin typeface="Inter"/>
+                <a:latin typeface="Calibri"/>
               </a:rPr>
               <a:t>Five outcomes leadership can point to</a:t>
             </a:r>
@@ -15018,7 +15018,7 @@
                 <a:solidFill>
                   <a:srgbClr val="FFFFFF"/>
                 </a:solidFill>
-                <a:latin typeface="Inter"/>
+                <a:latin typeface="Calibri"/>
               </a:rPr>
               <a:t>1</a:t>
             </a:r>
@@ -15060,7 +15060,7 @@
                 <a:solidFill>
                   <a:srgbClr val="09131B"/>
                 </a:solidFill>
-                <a:latin typeface="Inter"/>
+                <a:latin typeface="Calibri"/>
               </a:rPr>
               <a:t>Stop duplicate spend</a:t>
             </a:r>
@@ -15079,7 +15079,7 @@
                 <a:solidFill>
                   <a:srgbClr val="595959"/>
                 </a:solidFill>
-                <a:latin typeface="Inter"/>
+                <a:latin typeface="Calibri"/>
               </a:rPr>
               <a:t>Overlap is caught at the point of request, before commitment — direct, recurring savings.</a:t>
             </a:r>
@@ -15121,7 +15121,7 @@
                 <a:solidFill>
                   <a:srgbClr val="1E7F4F"/>
                 </a:solidFill>
-                <a:latin typeface="Inter"/>
+                <a:latin typeface="Calibri"/>
               </a:rPr>
               <a:t>PROCUREMENT</a:t>
             </a:r>
@@ -15257,7 +15257,7 @@
                 <a:solidFill>
                   <a:srgbClr val="FFFFFF"/>
                 </a:solidFill>
-                <a:latin typeface="Inter"/>
+                <a:latin typeface="Calibri"/>
               </a:rPr>
               <a:t>2</a:t>
             </a:r>
@@ -15299,7 +15299,7 @@
                 <a:solidFill>
                   <a:srgbClr val="09131B"/>
                 </a:solidFill>
-                <a:latin typeface="Inter"/>
+                <a:latin typeface="Calibri"/>
               </a:rPr>
               <a:t>Never miss a renewal</a:t>
             </a:r>
@@ -15318,7 +15318,7 @@
                 <a:solidFill>
                   <a:srgbClr val="595959"/>
                 </a:solidFill>
-                <a:latin typeface="Inter"/>
+                <a:latin typeface="Calibri"/>
               </a:rPr>
               <a:t>Automated 30/60/90 reminders plus impact-aware warnings end lapses and rushed, low-leverage renewals.</a:t>
             </a:r>
@@ -15360,7 +15360,7 @@
                 <a:solidFill>
                   <a:srgbClr val="1E7F4F"/>
                 </a:solidFill>
-                <a:latin typeface="Inter"/>
+                <a:latin typeface="Calibri"/>
               </a:rPr>
               <a:t>LEGAL / CONTINUITY</a:t>
             </a:r>
@@ -15496,7 +15496,7 @@
                 <a:solidFill>
                   <a:srgbClr val="FFFFFF"/>
                 </a:solidFill>
-                <a:latin typeface="Inter"/>
+                <a:latin typeface="Calibri"/>
               </a:rPr>
               <a:t>3</a:t>
             </a:r>
@@ -15538,7 +15538,7 @@
                 <a:solidFill>
                   <a:srgbClr val="09131B"/>
                 </a:solidFill>
-                <a:latin typeface="Inter"/>
+                <a:latin typeface="Calibri"/>
               </a:rPr>
               <a:t>Negotiate from strength</a:t>
             </a:r>
@@ -15557,7 +15557,7 @@
                 <a:solidFill>
                   <a:srgbClr val="595959"/>
                 </a:solidFill>
-                <a:latin typeface="Inter"/>
+                <a:latin typeface="Calibri"/>
               </a:rPr>
               <a:t>Vendor value, concentration and coverage analytics turn renewals into informed negotiations.</a:t>
             </a:r>
@@ -15599,7 +15599,7 @@
                 <a:solidFill>
                   <a:srgbClr val="1E7F4F"/>
                 </a:solidFill>
-                <a:latin typeface="Inter"/>
+                <a:latin typeface="Calibri"/>
               </a:rPr>
               <a:t>PROCUREMENT / CI</a:t>
             </a:r>
@@ -15735,7 +15735,7 @@
                 <a:solidFill>
                   <a:srgbClr val="FFFFFF"/>
                 </a:solidFill>
-                <a:latin typeface="Inter"/>
+                <a:latin typeface="Calibri"/>
               </a:rPr>
               <a:t>4</a:t>
             </a:r>
@@ -15777,7 +15777,7 @@
                 <a:solidFill>
                   <a:srgbClr val="09131B"/>
                 </a:solidFill>
-                <a:latin typeface="Inter"/>
+                <a:latin typeface="Calibri"/>
               </a:rPr>
               <a:t>Audit-ready by default</a:t>
             </a:r>
@@ -15796,7 +15796,7 @@
                 <a:solidFill>
                   <a:srgbClr val="595959"/>
                 </a:solidFill>
-                <a:latin typeface="Inter"/>
+                <a:latin typeface="Calibri"/>
               </a:rPr>
               <a:t>Automatic PII/PHI classification and full lineage make governance the default, not a project.</a:t>
             </a:r>
@@ -15838,7 +15838,7 @@
                 <a:solidFill>
                   <a:srgbClr val="1E7F4F"/>
                 </a:solidFill>
-                <a:latin typeface="Inter"/>
+                <a:latin typeface="Calibri"/>
               </a:rPr>
               <a:t>COMPLIANCE</a:t>
             </a:r>
@@ -15974,7 +15974,7 @@
                 <a:solidFill>
                   <a:srgbClr val="FFFFFF"/>
                 </a:solidFill>
-                <a:latin typeface="Inter"/>
+                <a:latin typeface="Calibri"/>
               </a:rPr>
               <a:t>5</a:t>
             </a:r>
@@ -16016,7 +16016,7 @@
                 <a:solidFill>
                   <a:srgbClr val="09131B"/>
                 </a:solidFill>
-                <a:latin typeface="Inter"/>
+                <a:latin typeface="Calibri"/>
               </a:rPr>
               <a:t>Faster, confident decisions</a:t>
             </a:r>
@@ -16035,7 +16035,7 @@
                 <a:solidFill>
                   <a:srgbClr val="595959"/>
                 </a:solidFill>
-                <a:latin typeface="Inter"/>
+                <a:latin typeface="Calibri"/>
               </a:rPr>
               <a:t>One source of truth and a natural-language ask cut manual lookups and let teams trust the number.</a:t>
             </a:r>
@@ -16077,7 +16077,7 @@
                 <a:solidFill>
                   <a:srgbClr val="1E7F4F"/>
                 </a:solidFill>
-                <a:latin typeface="Inter"/>
+                <a:latin typeface="Calibri"/>
               </a:rPr>
               <a:t>COMMERCIAL INSIGHTS</a:t>
             </a:r>
@@ -16163,7 +16163,7 @@
                 <a:solidFill>
                   <a:srgbClr val="A9AFB6"/>
                 </a:solidFill>
-                <a:latin typeface="Inter"/>
+                <a:latin typeface="Calibri"/>
               </a:rPr>
               <a:t>Cortex Atlas  ·  Illustrative prototype, synthetic data  ·  Confidential</a:t>
             </a:r>
@@ -16205,7 +16205,7 @@
                 <a:solidFill>
                   <a:srgbClr val="A9AFB6"/>
                 </a:solidFill>
-                <a:latin typeface="Inter"/>
+                <a:latin typeface="Calibri"/>
               </a:rPr>
               <a:t>13</a:t>
             </a:r>
@@ -16317,7 +16317,7 @@
                 <a:solidFill>
                   <a:srgbClr val="F89739"/>
                 </a:solidFill>
-                <a:latin typeface="Inter"/>
+                <a:latin typeface="Calibri"/>
               </a:rPr>
               <a:t>DESIGN &amp; ARCHITECTURE</a:t>
             </a:r>
@@ -16359,7 +16359,7 @@
                 <a:solidFill>
                   <a:srgbClr val="09131B"/>
                 </a:solidFill>
-                <a:latin typeface="Inter"/>
+                <a:latin typeface="Calibri"/>
               </a:rPr>
               <a:t>Built to drop into your Microsoft estate — and the Cortex suite</a:t>
             </a:r>
@@ -16449,7 +16449,7 @@
                 <a:solidFill>
                   <a:srgbClr val="09131B"/>
                 </a:solidFill>
-                <a:latin typeface="Inter"/>
+                <a:latin typeface="Calibri"/>
               </a:rPr>
               <a:t>The prototype you're seeing</a:t>
             </a:r>
@@ -16458,7 +16458,7 @@
                 <a:solidFill>
                   <a:srgbClr val="F89739"/>
                 </a:solidFill>
-                <a:latin typeface="Inter"/>
+                <a:latin typeface="Calibri"/>
               </a:rPr>
               <a:t>—  </a:t>
             </a:r>
@@ -16467,7 +16467,7 @@
                 <a:solidFill>
                   <a:srgbClr val="09131B"/>
                 </a:solidFill>
-                <a:latin typeface="Inter"/>
+                <a:latin typeface="Calibri"/>
               </a:rPr>
               <a:t>One self-contained file.</a:t>
             </a:r>
@@ -16476,7 +16476,7 @@
                 <a:solidFill>
                   <a:srgbClr val="595959"/>
                 </a:solidFill>
-                <a:latin typeface="Inter"/>
+                <a:latin typeface="Calibri"/>
               </a:rPr>
               <a:t> Runs in any browser, fully offline — no install to evaluate it.</a:t>
             </a:r>
@@ -16495,7 +16495,7 @@
                 <a:solidFill>
                   <a:srgbClr val="F89739"/>
                 </a:solidFill>
-                <a:latin typeface="Inter"/>
+                <a:latin typeface="Calibri"/>
               </a:rPr>
               <a:t>—  </a:t>
             </a:r>
@@ -16504,7 +16504,7 @@
                 <a:solidFill>
                   <a:srgbClr val="09131B"/>
                 </a:solidFill>
-                <a:latin typeface="Inter"/>
+                <a:latin typeface="Calibri"/>
               </a:rPr>
               <a:t>Cortex design system.</a:t>
             </a:r>
@@ -16513,7 +16513,7 @@
                 <a:solidFill>
                   <a:srgbClr val="595959"/>
                 </a:solidFill>
-                <a:latin typeface="Inter"/>
+                <a:latin typeface="Calibri"/>
               </a:rPr>
               <a:t> Same look and behaviour as Compass, Vantage and Meridian.</a:t>
             </a:r>
@@ -16532,7 +16532,7 @@
                 <a:solidFill>
                   <a:srgbClr val="F89739"/>
                 </a:solidFill>
-                <a:latin typeface="Inter"/>
+                <a:latin typeface="Calibri"/>
               </a:rPr>
               <a:t>—  </a:t>
             </a:r>
@@ -16541,7 +16541,7 @@
                 <a:solidFill>
                   <a:srgbClr val="09131B"/>
                 </a:solidFill>
-                <a:latin typeface="Inter"/>
+                <a:latin typeface="Calibri"/>
               </a:rPr>
               <a:t>Lift-and-shift ready.</a:t>
             </a:r>
@@ -16550,7 +16550,7 @@
                 <a:solidFill>
                   <a:srgbClr val="595959"/>
                 </a:solidFill>
-                <a:latin typeface="Inter"/>
+                <a:latin typeface="Calibri"/>
               </a:rPr>
               <a:t> Drops into the cortex-commercial-suite with near-zero rework.</a:t>
             </a:r>
@@ -16569,7 +16569,7 @@
                 <a:solidFill>
                   <a:srgbClr val="F89739"/>
                 </a:solidFill>
-                <a:latin typeface="Inter"/>
+                <a:latin typeface="Calibri"/>
               </a:rPr>
               <a:t>—  </a:t>
             </a:r>
@@ -16578,7 +16578,7 @@
                 <a:solidFill>
                   <a:srgbClr val="09131B"/>
                 </a:solidFill>
-                <a:latin typeface="Inter"/>
+                <a:latin typeface="Calibri"/>
               </a:rPr>
               <a:t>Synthetic data only.</a:t>
             </a:r>
@@ -16587,7 +16587,7 @@
                 <a:solidFill>
                   <a:srgbClr val="595959"/>
                 </a:solidFill>
-                <a:latin typeface="Inter"/>
+                <a:latin typeface="Calibri"/>
               </a:rPr>
               <a:t> No real client or patient data anywhere in the prototype.</a:t>
             </a:r>
@@ -16677,7 +16677,7 @@
                 <a:solidFill>
                   <a:srgbClr val="09131B"/>
                 </a:solidFill>
-                <a:latin typeface="Inter"/>
+                <a:latin typeface="Calibri"/>
               </a:rPr>
               <a:t>Target production stack — Microsoft-native</a:t>
             </a:r>
@@ -16765,7 +16765,7 @@
                 <a:solidFill>
                   <a:srgbClr val="09131B"/>
                 </a:solidFill>
-                <a:latin typeface="Inter"/>
+                <a:latin typeface="Calibri"/>
               </a:rPr>
               <a:t>SharePoint</a:t>
             </a:r>
@@ -16784,7 +16784,7 @@
                 <a:solidFill>
                   <a:srgbClr val="595959"/>
                 </a:solidFill>
-                <a:latin typeface="Inter"/>
+                <a:latin typeface="Calibri"/>
               </a:rPr>
               <a:t>Storage &amp; lists — the records system</a:t>
             </a:r>
@@ -16872,7 +16872,7 @@
                 <a:solidFill>
                   <a:srgbClr val="09131B"/>
                 </a:solidFill>
-                <a:latin typeface="Inter"/>
+                <a:latin typeface="Calibri"/>
               </a:rPr>
               <a:t>Power Automate</a:t>
             </a:r>
@@ -16891,7 +16891,7 @@
                 <a:solidFill>
                   <a:srgbClr val="595959"/>
                 </a:solidFill>
-                <a:latin typeface="Inter"/>
+                <a:latin typeface="Calibri"/>
               </a:rPr>
               <a:t>Workflow &amp; the 30/60/90 reminders</a:t>
             </a:r>
@@ -16979,7 +16979,7 @@
                 <a:solidFill>
                   <a:srgbClr val="09131B"/>
                 </a:solidFill>
-                <a:latin typeface="Inter"/>
+                <a:latin typeface="Calibri"/>
               </a:rPr>
               <a:t>Microsoft Purview</a:t>
             </a:r>
@@ -16998,7 +16998,7 @@
                 <a:solidFill>
                   <a:srgbClr val="595959"/>
                 </a:solidFill>
-                <a:latin typeface="Inter"/>
+                <a:latin typeface="Calibri"/>
               </a:rPr>
               <a:t>Catalogue, classification &amp; lineage</a:t>
             </a:r>
@@ -17086,7 +17086,7 @@
                 <a:solidFill>
                   <a:srgbClr val="09131B"/>
                 </a:solidFill>
-                <a:latin typeface="Inter"/>
+                <a:latin typeface="Calibri"/>
               </a:rPr>
               <a:t>Azure OpenAI</a:t>
             </a:r>
@@ -17105,7 +17105,7 @@
                 <a:solidFill>
                   <a:srgbClr val="595959"/>
                 </a:solidFill>
-                <a:latin typeface="Inter"/>
+                <a:latin typeface="Calibri"/>
               </a:rPr>
               <a:t>The intelligence &amp; Ask Atlas layer</a:t>
             </a:r>
@@ -17193,7 +17193,7 @@
                 <a:solidFill>
                   <a:srgbClr val="09131B"/>
                 </a:solidFill>
-                <a:latin typeface="Inter"/>
+                <a:latin typeface="Calibri"/>
               </a:rPr>
               <a:t>Databricks / Model N / SAP</a:t>
             </a:r>
@@ -17212,7 +17212,7 @@
                 <a:solidFill>
                   <a:srgbClr val="595959"/>
                 </a:solidFill>
-                <a:latin typeface="Inter"/>
+                <a:latin typeface="Calibri"/>
               </a:rPr>
               <a:t>Data, spend and contract feeds</a:t>
             </a:r>
@@ -17298,7 +17298,7 @@
                 <a:solidFill>
                   <a:srgbClr val="A9AFB6"/>
                 </a:solidFill>
-                <a:latin typeface="Inter"/>
+                <a:latin typeface="Calibri"/>
               </a:rPr>
               <a:t>Cortex Atlas  ·  Illustrative prototype, synthetic data  ·  Confidential</a:t>
             </a:r>
@@ -17340,7 +17340,7 @@
                 <a:solidFill>
                   <a:srgbClr val="A9AFB6"/>
                 </a:solidFill>
-                <a:latin typeface="Inter"/>
+                <a:latin typeface="Calibri"/>
               </a:rPr>
               <a:t>14</a:t>
             </a:r>
@@ -17452,7 +17452,7 @@
                 <a:solidFill>
                   <a:srgbClr val="F89739"/>
                 </a:solidFill>
-                <a:latin typeface="Inter"/>
+                <a:latin typeface="Calibri"/>
               </a:rPr>
               <a:t>AGENDA</a:t>
             </a:r>
@@ -17494,7 +17494,7 @@
                 <a:solidFill>
                   <a:srgbClr val="09131B"/>
                 </a:solidFill>
-                <a:latin typeface="Inter"/>
+                <a:latin typeface="Calibri"/>
               </a:rPr>
               <a:t>What we'll cover today</a:t>
             </a:r>
@@ -17630,7 +17630,7 @@
                 <a:solidFill>
                   <a:srgbClr val="09131B"/>
                 </a:solidFill>
-                <a:latin typeface="Inter"/>
+                <a:latin typeface="Calibri"/>
               </a:rPr>
               <a:t>01</a:t>
             </a:r>
@@ -17672,7 +17672,7 @@
                 <a:solidFill>
                   <a:srgbClr val="09131B"/>
                 </a:solidFill>
-                <a:latin typeface="Inter"/>
+                <a:latin typeface="Calibri"/>
               </a:rPr>
               <a:t>The challenge</a:t>
             </a:r>
@@ -17691,7 +17691,7 @@
                 <a:solidFill>
                   <a:srgbClr val="595959"/>
                 </a:solidFill>
-                <a:latin typeface="Inter"/>
+                <a:latin typeface="Calibri"/>
               </a:rPr>
               <a:t>Five tools, five silos — and what that costs</a:t>
             </a:r>
@@ -17827,7 +17827,7 @@
                 <a:solidFill>
                   <a:srgbClr val="09131B"/>
                 </a:solidFill>
-                <a:latin typeface="Inter"/>
+                <a:latin typeface="Calibri"/>
               </a:rPr>
               <a:t>02</a:t>
             </a:r>
@@ -17869,7 +17869,7 @@
                 <a:solidFill>
                   <a:srgbClr val="09131B"/>
                 </a:solidFill>
-                <a:latin typeface="Inter"/>
+                <a:latin typeface="Calibri"/>
               </a:rPr>
               <a:t>The solution</a:t>
             </a:r>
@@ -17888,7 +17888,7 @@
                 <a:solidFill>
                   <a:srgbClr val="595959"/>
                 </a:solidFill>
-                <a:latin typeface="Inter"/>
+                <a:latin typeface="Calibri"/>
               </a:rPr>
               <a:t>Cortex Atlas: one connected estate</a:t>
             </a:r>
@@ -18024,7 +18024,7 @@
                 <a:solidFill>
                   <a:srgbClr val="09131B"/>
                 </a:solidFill>
-                <a:latin typeface="Inter"/>
+                <a:latin typeface="Calibri"/>
               </a:rPr>
               <a:t>03</a:t>
             </a:r>
@@ -18066,7 +18066,7 @@
                 <a:solidFill>
                   <a:srgbClr val="09131B"/>
                 </a:solidFill>
-                <a:latin typeface="Inter"/>
+                <a:latin typeface="Calibri"/>
               </a:rPr>
               <a:t>Inside the platform</a:t>
             </a:r>
@@ -18085,7 +18085,7 @@
                 <a:solidFill>
                   <a:srgbClr val="595959"/>
                 </a:solidFill>
-                <a:latin typeface="Inter"/>
+                <a:latin typeface="Calibri"/>
               </a:rPr>
               <a:t>A guided walk through all five tools</a:t>
             </a:r>
@@ -18221,7 +18221,7 @@
                 <a:solidFill>
                   <a:srgbClr val="09131B"/>
                 </a:solidFill>
-                <a:latin typeface="Inter"/>
+                <a:latin typeface="Calibri"/>
               </a:rPr>
               <a:t>04</a:t>
             </a:r>
@@ -18263,7 +18263,7 @@
                 <a:solidFill>
                   <a:srgbClr val="09131B"/>
                 </a:solidFill>
-                <a:latin typeface="Inter"/>
+                <a:latin typeface="Calibri"/>
               </a:rPr>
               <a:t>The decision layer</a:t>
             </a:r>
@@ -18282,7 +18282,7 @@
                 <a:solidFill>
                   <a:srgbClr val="595959"/>
                 </a:solidFill>
-                <a:latin typeface="Inter"/>
+                <a:latin typeface="Calibri"/>
               </a:rPr>
               <a:t>Automation and intelligence built in</a:t>
             </a:r>
@@ -18418,7 +18418,7 @@
                 <a:solidFill>
                   <a:srgbClr val="09131B"/>
                 </a:solidFill>
-                <a:latin typeface="Inter"/>
+                <a:latin typeface="Calibri"/>
               </a:rPr>
               <a:t>05</a:t>
             </a:r>
@@ -18460,7 +18460,7 @@
                 <a:solidFill>
                   <a:srgbClr val="09131B"/>
                 </a:solidFill>
-                <a:latin typeface="Inter"/>
+                <a:latin typeface="Calibri"/>
               </a:rPr>
               <a:t>Value &amp; outcomes</a:t>
             </a:r>
@@ -18479,7 +18479,7 @@
                 <a:solidFill>
                   <a:srgbClr val="595959"/>
                 </a:solidFill>
-                <a:latin typeface="Inter"/>
+                <a:latin typeface="Calibri"/>
               </a:rPr>
               <a:t>What the business gets</a:t>
             </a:r>
@@ -18615,7 +18615,7 @@
                 <a:solidFill>
                   <a:srgbClr val="09131B"/>
                 </a:solidFill>
-                <a:latin typeface="Inter"/>
+                <a:latin typeface="Calibri"/>
               </a:rPr>
               <a:t>06</a:t>
             </a:r>
@@ -18657,7 +18657,7 @@
                 <a:solidFill>
                   <a:srgbClr val="09131B"/>
                 </a:solidFill>
-                <a:latin typeface="Inter"/>
+                <a:latin typeface="Calibri"/>
               </a:rPr>
               <a:t>Delivery &amp; next steps</a:t>
             </a:r>
@@ -18676,7 +18676,7 @@
                 <a:solidFill>
                   <a:srgbClr val="595959"/>
                 </a:solidFill>
-                <a:latin typeface="Inter"/>
+                <a:latin typeface="Calibri"/>
               </a:rPr>
               <a:t>Architecture, roadmap, and how we start</a:t>
             </a:r>
@@ -18762,7 +18762,7 @@
                 <a:solidFill>
                   <a:srgbClr val="A9AFB6"/>
                 </a:solidFill>
-                <a:latin typeface="Inter"/>
+                <a:latin typeface="Calibri"/>
               </a:rPr>
               <a:t>Cortex Atlas  ·  Illustrative prototype, synthetic data  ·  Confidential</a:t>
             </a:r>
@@ -18804,7 +18804,7 @@
                 <a:solidFill>
                   <a:srgbClr val="A9AFB6"/>
                 </a:solidFill>
-                <a:latin typeface="Inter"/>
+                <a:latin typeface="Calibri"/>
               </a:rPr>
               <a:t>1</a:t>
             </a:r>
@@ -18916,7 +18916,7 @@
                 <a:solidFill>
                   <a:srgbClr val="F89739"/>
                 </a:solidFill>
-                <a:latin typeface="Inter"/>
+                <a:latin typeface="Calibri"/>
               </a:rPr>
               <a:t>DELIVERY ROADMAP</a:t>
             </a:r>
@@ -18958,7 +18958,7 @@
                 <a:solidFill>
                   <a:srgbClr val="09131B"/>
                 </a:solidFill>
-                <a:latin typeface="Inter"/>
+                <a:latin typeface="Calibri"/>
               </a:rPr>
               <a:t>A phased rollout — value at every step</a:t>
             </a:r>
@@ -19094,7 +19094,7 @@
                 <a:solidFill>
                   <a:srgbClr val="0563C1"/>
                 </a:solidFill>
-                <a:latin typeface="Inter"/>
+                <a:latin typeface="Calibri"/>
               </a:rPr>
               <a:t>PHASE 1</a:t>
             </a:r>
@@ -19113,7 +19113,7 @@
                 <a:solidFill>
                   <a:srgbClr val="09131B"/>
                 </a:solidFill>
-                <a:latin typeface="Inter"/>
+                <a:latin typeface="Calibri"/>
               </a:rPr>
               <a:t>Foundation</a:t>
             </a:r>
@@ -19132,7 +19132,7 @@
                 <a:solidFill>
                   <a:srgbClr val="595959"/>
                 </a:solidFill>
-                <a:latin typeface="Inter"/>
+                <a:latin typeface="Calibri"/>
               </a:rPr>
               <a:t>Migrate the five tools, the data model and the cross-links onto SharePoint. The as-is estate, connected and trustworthy.</a:t>
             </a:r>
@@ -19174,7 +19174,7 @@
                 <a:solidFill>
                   <a:srgbClr val="A9AFB6"/>
                 </a:solidFill>
-                <a:latin typeface="Inter"/>
+                <a:latin typeface="Calibri"/>
               </a:rPr>
               <a:t>→</a:t>
             </a:r>
@@ -19310,7 +19310,7 @@
                 <a:solidFill>
                   <a:srgbClr val="9A5C12"/>
                 </a:solidFill>
-                <a:latin typeface="Inter"/>
+                <a:latin typeface="Calibri"/>
               </a:rPr>
               <a:t>PHASE 2</a:t>
             </a:r>
@@ -19329,7 +19329,7 @@
                 <a:solidFill>
                   <a:srgbClr val="09131B"/>
                 </a:solidFill>
-                <a:latin typeface="Inter"/>
+                <a:latin typeface="Calibri"/>
               </a:rPr>
               <a:t>Automation</a:t>
             </a:r>
@@ -19348,7 +19348,7 @@
                 <a:solidFill>
                   <a:srgbClr val="595959"/>
                 </a:solidFill>
-                <a:latin typeface="Inter"/>
+                <a:latin typeface="Calibri"/>
               </a:rPr>
               <a:t>Power Automate reminders, approved-request → catalogue sync, renewal pre-fill, Purview PII/PHI classification, duplicate detection.</a:t>
             </a:r>
@@ -19390,7 +19390,7 @@
                 <a:solidFill>
                   <a:srgbClr val="A9AFB6"/>
                 </a:solidFill>
-                <a:latin typeface="Inter"/>
+                <a:latin typeface="Calibri"/>
               </a:rPr>
               <a:t>→</a:t>
             </a:r>
@@ -19526,7 +19526,7 @@
                 <a:solidFill>
                   <a:srgbClr val="1E7F4F"/>
                 </a:solidFill>
-                <a:latin typeface="Inter"/>
+                <a:latin typeface="Calibri"/>
               </a:rPr>
               <a:t>PHASE 3</a:t>
             </a:r>
@@ -19545,7 +19545,7 @@
                 <a:solidFill>
                   <a:srgbClr val="09131B"/>
                 </a:solidFill>
-                <a:latin typeface="Inter"/>
+                <a:latin typeface="Calibri"/>
               </a:rPr>
               <a:t>Intelligence</a:t>
             </a:r>
@@ -19564,7 +19564,7 @@
                 <a:solidFill>
                   <a:srgbClr val="595959"/>
                 </a:solidFill>
-                <a:latin typeface="Inter"/>
+                <a:latin typeface="Calibri"/>
               </a:rPr>
               <a:t>Vendor Hub Plus, renewal prediction, cross-tool signals and Ask Atlas on Azure OpenAI — the full decision layer.</a:t>
             </a:r>
@@ -19606,7 +19606,7 @@
                 <a:solidFill>
                   <a:srgbClr val="09131B"/>
                 </a:solidFill>
-                <a:latin typeface="Inter"/>
+                <a:latin typeface="Calibri"/>
               </a:rPr>
               <a:t>The prototype already demonstrates all three layers — so each phase de-risks the next, and you see working value from Phase 1 onward.</a:t>
             </a:r>
@@ -19692,7 +19692,7 @@
                 <a:solidFill>
                   <a:srgbClr val="A9AFB6"/>
                 </a:solidFill>
-                <a:latin typeface="Inter"/>
+                <a:latin typeface="Calibri"/>
               </a:rPr>
               <a:t>Cortex Atlas  ·  Illustrative prototype, synthetic data  ·  Confidential</a:t>
             </a:r>
@@ -19734,7 +19734,7 @@
                 <a:solidFill>
                   <a:srgbClr val="A9AFB6"/>
                 </a:solidFill>
-                <a:latin typeface="Inter"/>
+                <a:latin typeface="Calibri"/>
               </a:rPr>
               <a:t>15</a:t>
             </a:r>
@@ -19846,7 +19846,7 @@
                 <a:solidFill>
                   <a:srgbClr val="F89739"/>
                 </a:solidFill>
-                <a:latin typeface="Inter"/>
+                <a:latin typeface="Calibri"/>
               </a:rPr>
               <a:t>WHY THIS APPROACH</a:t>
             </a:r>
@@ -19888,7 +19888,7 @@
                 <a:solidFill>
                   <a:srgbClr val="09131B"/>
                 </a:solidFill>
-                <a:latin typeface="Inter"/>
+                <a:latin typeface="Calibri"/>
               </a:rPr>
               <a:t>Lower risk, faster value, proven pattern</a:t>
             </a:r>
@@ -20024,7 +20024,7 @@
                 <a:solidFill>
                   <a:srgbClr val="FFFFFF"/>
                 </a:solidFill>
-                <a:latin typeface="Inter"/>
+                <a:latin typeface="Calibri"/>
               </a:rPr>
               <a:t>✓</a:t>
             </a:r>
@@ -20066,7 +20066,7 @@
                 <a:solidFill>
                   <a:srgbClr val="09131B"/>
                 </a:solidFill>
-                <a:latin typeface="Inter"/>
+                <a:latin typeface="Calibri"/>
               </a:rPr>
               <a:t>Proven in the suite</a:t>
             </a:r>
@@ -20085,7 +20085,7 @@
                 <a:solidFill>
                   <a:srgbClr val="595959"/>
                 </a:solidFill>
-                <a:latin typeface="Inter"/>
+                <a:latin typeface="Calibri"/>
               </a:rPr>
               <a:t>Atlas reuses the exact design and structure as Compass, Vantage and Meridian — a pattern already delivered, not invented here.</a:t>
             </a:r>
@@ -20221,7 +20221,7 @@
                 <a:solidFill>
                   <a:srgbClr val="FFFFFF"/>
                 </a:solidFill>
-                <a:latin typeface="Inter"/>
+                <a:latin typeface="Calibri"/>
               </a:rPr>
               <a:t>✓</a:t>
             </a:r>
@@ -20263,7 +20263,7 @@
                 <a:solidFill>
                   <a:srgbClr val="09131B"/>
                 </a:solidFill>
-                <a:latin typeface="Inter"/>
+                <a:latin typeface="Calibri"/>
               </a:rPr>
               <a:t>Your stack, orchestrated</a:t>
             </a:r>
@@ -20282,7 +20282,7 @@
                 <a:solidFill>
                   <a:srgbClr val="595959"/>
                 </a:solidFill>
-                <a:latin typeface="Inter"/>
+                <a:latin typeface="Calibri"/>
               </a:rPr>
               <a:t>Built on Microsoft tools you already own — minimal new procurement, security or training overhead.</a:t>
             </a:r>
@@ -20418,7 +20418,7 @@
                 <a:solidFill>
                   <a:srgbClr val="FFFFFF"/>
                 </a:solidFill>
-                <a:latin typeface="Inter"/>
+                <a:latin typeface="Calibri"/>
               </a:rPr>
               <a:t>✓</a:t>
             </a:r>
@@ -20460,7 +20460,7 @@
                 <a:solidFill>
                   <a:srgbClr val="09131B"/>
                 </a:solidFill>
-                <a:latin typeface="Inter"/>
+                <a:latin typeface="Calibri"/>
               </a:rPr>
               <a:t>Evaluate it today</a:t>
             </a:r>
@@ -20479,7 +20479,7 @@
                 <a:solidFill>
                   <a:srgbClr val="595959"/>
                 </a:solidFill>
-                <a:latin typeface="Inter"/>
+                <a:latin typeface="Calibri"/>
               </a:rPr>
               <a:t>A working, offline prototype means stakeholders can click through and react now — no leap of faith.</a:t>
             </a:r>
@@ -20615,7 +20615,7 @@
                 <a:solidFill>
                   <a:srgbClr val="FFFFFF"/>
                 </a:solidFill>
-                <a:latin typeface="Inter"/>
+                <a:latin typeface="Calibri"/>
               </a:rPr>
               <a:t>✓</a:t>
             </a:r>
@@ -20657,7 +20657,7 @@
                 <a:solidFill>
                   <a:srgbClr val="09131B"/>
                 </a:solidFill>
-                <a:latin typeface="Inter"/>
+                <a:latin typeface="Calibri"/>
               </a:rPr>
               <a:t>Built to grow</a:t>
             </a:r>
@@ -20676,7 +20676,7 @@
                 <a:solidFill>
                   <a:srgbClr val="595959"/>
                 </a:solidFill>
-                <a:latin typeface="Inter"/>
+                <a:latin typeface="Calibri"/>
               </a:rPr>
               <a:t>Clean module separation means automation and intelligence bolt on without a rewrite.</a:t>
             </a:r>
@@ -20762,7 +20762,7 @@
                 <a:solidFill>
                   <a:srgbClr val="A9AFB6"/>
                 </a:solidFill>
-                <a:latin typeface="Inter"/>
+                <a:latin typeface="Calibri"/>
               </a:rPr>
               <a:t>Cortex Atlas  ·  Illustrative prototype, synthetic data  ·  Confidential</a:t>
             </a:r>
@@ -20804,7 +20804,7 @@
                 <a:solidFill>
                   <a:srgbClr val="A9AFB6"/>
                 </a:solidFill>
-                <a:latin typeface="Inter"/>
+                <a:latin typeface="Calibri"/>
               </a:rPr>
               <a:t>16</a:t>
             </a:r>
@@ -20916,7 +20916,7 @@
                 <a:solidFill>
                   <a:srgbClr val="F89739"/>
                 </a:solidFill>
-                <a:latin typeface="Inter"/>
+                <a:latin typeface="Calibri"/>
               </a:rPr>
               <a:t>NEXT STEPS</a:t>
             </a:r>
@@ -20958,7 +20958,7 @@
                 <a:solidFill>
                   <a:srgbClr val="FFFFFF"/>
                 </a:solidFill>
-                <a:latin typeface="Inter"/>
+                <a:latin typeface="Calibri"/>
               </a:rPr>
               <a:t>How we start</a:t>
             </a:r>
@@ -21046,7 +21046,7 @@
                 <a:solidFill>
                   <a:srgbClr val="09131B"/>
                 </a:solidFill>
-                <a:latin typeface="Inter"/>
+                <a:latin typeface="Calibri"/>
               </a:rPr>
               <a:t>1</a:t>
             </a:r>
@@ -21088,7 +21088,7 @@
                 <a:solidFill>
                   <a:srgbClr val="FFFFFF"/>
                 </a:solidFill>
-                <a:latin typeface="Inter"/>
+                <a:latin typeface="Calibri"/>
               </a:rPr>
               <a:t>Walk the prototype live</a:t>
             </a:r>
@@ -21107,7 +21107,7 @@
                 <a:solidFill>
                   <a:srgbClr val="C7CCD3"/>
                 </a:solidFill>
-                <a:latin typeface="Inter"/>
+                <a:latin typeface="Calibri"/>
               </a:rPr>
               <a:t>A hands-on session with your CI and procurement leads — react to the real thing.</a:t>
             </a:r>
@@ -21195,7 +21195,7 @@
                 <a:solidFill>
                   <a:srgbClr val="09131B"/>
                 </a:solidFill>
-                <a:latin typeface="Inter"/>
+                <a:latin typeface="Calibri"/>
               </a:rPr>
               <a:t>2</a:t>
             </a:r>
@@ -21237,7 +21237,7 @@
                 <a:solidFill>
                   <a:srgbClr val="FFFFFF"/>
                 </a:solidFill>
-                <a:latin typeface="Inter"/>
+                <a:latin typeface="Calibri"/>
               </a:rPr>
               <a:t>Baseline data audit</a:t>
             </a:r>
@@ -21256,7 +21256,7 @@
                 <a:solidFill>
                   <a:srgbClr val="C7CCD3"/>
                 </a:solidFill>
-                <a:latin typeface="Inter"/>
+                <a:latin typeface="Calibri"/>
               </a:rPr>
               <a:t>Point Atlas at your real estate to quantify duplication, renewal risk and concentration — the disclaimer becomes real numbers.</a:t>
             </a:r>
@@ -21344,7 +21344,7 @@
                 <a:solidFill>
                   <a:srgbClr val="09131B"/>
                 </a:solidFill>
-                <a:latin typeface="Inter"/>
+                <a:latin typeface="Calibri"/>
               </a:rPr>
               <a:t>3</a:t>
             </a:r>
@@ -21386,7 +21386,7 @@
                 <a:solidFill>
                   <a:srgbClr val="FFFFFF"/>
                 </a:solidFill>
-                <a:latin typeface="Inter"/>
+                <a:latin typeface="Calibri"/>
               </a:rPr>
               <a:t>Confirm scope &amp; architecture</a:t>
             </a:r>
@@ -21405,7 +21405,7 @@
                 <a:solidFill>
                   <a:srgbClr val="C7CCD3"/>
                 </a:solidFill>
-                <a:latin typeface="Inter"/>
+                <a:latin typeface="Calibri"/>
               </a:rPr>
               <a:t>Agree Phase 1 boundaries and the SharePoint / Power Automate / Purview target with your IT team.</a:t>
             </a:r>
@@ -21493,7 +21493,7 @@
                 <a:solidFill>
                   <a:srgbClr val="09131B"/>
                 </a:solidFill>
-                <a:latin typeface="Inter"/>
+                <a:latin typeface="Calibri"/>
               </a:rPr>
               <a:t>4</a:t>
             </a:r>
@@ -21535,7 +21535,7 @@
                 <a:solidFill>
                   <a:srgbClr val="FFFFFF"/>
                 </a:solidFill>
-                <a:latin typeface="Inter"/>
+                <a:latin typeface="Calibri"/>
               </a:rPr>
               <a:t>Stand up Phase 1</a:t>
             </a:r>
@@ -21554,7 +21554,7 @@
                 <a:solidFill>
                   <a:srgbClr val="C7CCD3"/>
                 </a:solidFill>
-                <a:latin typeface="Inter"/>
+                <a:latin typeface="Calibri"/>
               </a:rPr>
               <a:t>Migrate the connected five-tool foundation — value from day one.</a:t>
             </a:r>
@@ -21596,7 +21596,7 @@
                 <a:solidFill>
                   <a:srgbClr val="F89739"/>
                 </a:solidFill>
-                <a:latin typeface="Inter"/>
+                <a:latin typeface="Calibri"/>
               </a:rPr>
               <a:t>Thank you.  Let's open the prototype.</a:t>
             </a:r>
@@ -21708,7 +21708,7 @@
                 <a:solidFill>
                   <a:srgbClr val="F89739"/>
                 </a:solidFill>
-                <a:latin typeface="Inter"/>
+                <a:latin typeface="Calibri"/>
               </a:rPr>
               <a:t>APPENDIX</a:t>
             </a:r>
@@ -21750,7 +21750,7 @@
                 <a:solidFill>
                   <a:srgbClr val="09131B"/>
                 </a:solidFill>
-                <a:latin typeface="Inter"/>
+                <a:latin typeface="Calibri"/>
               </a:rPr>
               <a:t>Notes, scope and disclaimer</a:t>
             </a:r>
@@ -21792,7 +21792,7 @@
                 <a:solidFill>
                   <a:srgbClr val="09131B"/>
                 </a:solidFill>
-                <a:latin typeface="Inter"/>
+                <a:latin typeface="Calibri"/>
               </a:rPr>
               <a:t>On the data</a:t>
             </a:r>
@@ -21811,7 +21811,7 @@
                 <a:solidFill>
                   <a:srgbClr val="595959"/>
                 </a:solidFill>
-                <a:latin typeface="Inter"/>
+                <a:latin typeface="Calibri"/>
               </a:rPr>
               <a:t>All figures, companies, brands and vendors in this prototype and deck are synthetic and illustrative (NovaCura Pharmaceuticals; brands OncoNova, Immunexa, CardioZen, Neurovia, RareGene; invented vendors such as Helix Health Data and Cardinal Claims Co). Public vendor names (Veeva, IQVIA, Databricks, Model N, SAP, SharePoint, Microsoft Purview) appear only as integration labels.</a:t>
             </a:r>
@@ -21830,7 +21830,7 @@
                 <a:solidFill>
                   <a:srgbClr val="09131B"/>
                 </a:solidFill>
-                <a:latin typeface="Inter"/>
+                <a:latin typeface="Calibri"/>
               </a:rPr>
               <a:t>On the figures</a:t>
             </a:r>
@@ -21849,7 +21849,7 @@
                 <a:solidFill>
                   <a:srgbClr val="595959"/>
                 </a:solidFill>
-                <a:latin typeface="Inter"/>
+                <a:latin typeface="Calibri"/>
               </a:rPr>
               <a:t>Numbers shown — spend, HHI, expiry counts, duplicate exposure — are directional and exist to demonstrate the mechanics. A client baseline audit is required before any figure is used externally or for decisions.</a:t>
             </a:r>
@@ -21868,7 +21868,7 @@
                 <a:solidFill>
                   <a:srgbClr val="09131B"/>
                 </a:solidFill>
-                <a:latin typeface="Inter"/>
+                <a:latin typeface="Calibri"/>
               </a:rPr>
               <a:t>On the intelligence</a:t>
             </a:r>
@@ -21887,7 +21887,7 @@
                 <a:solidFill>
                   <a:srgbClr val="595959"/>
                 </a:solidFill>
-                <a:latin typeface="Inter"/>
+                <a:latin typeface="Calibri"/>
               </a:rPr>
               <a:t>Every AI and analytics output in Atlas is advisory only, carries a confidence read, and requires human approval. There are no autonomous decisions or actions.</a:t>
             </a:r>
@@ -21973,7 +21973,7 @@
                 <a:solidFill>
                   <a:srgbClr val="A9AFB6"/>
                 </a:solidFill>
-                <a:latin typeface="Inter"/>
+                <a:latin typeface="Calibri"/>
               </a:rPr>
               <a:t>Cortex Atlas  ·  Illustrative prototype, synthetic data  ·  Confidential</a:t>
             </a:r>
@@ -22015,7 +22015,7 @@
                 <a:solidFill>
                   <a:srgbClr val="A9AFB6"/>
                 </a:solidFill>
-                <a:latin typeface="Inter"/>
+                <a:latin typeface="Calibri"/>
               </a:rPr>
               <a:t>17</a:t>
             </a:r>
@@ -22127,7 +22127,7 @@
                 <a:solidFill>
                   <a:srgbClr val="F89739"/>
                 </a:solidFill>
-                <a:latin typeface="Inter"/>
+                <a:latin typeface="Calibri"/>
               </a:rPr>
               <a:t>THE CHALLENGE</a:t>
             </a:r>
@@ -22169,7 +22169,7 @@
                 <a:solidFill>
                   <a:srgbClr val="FFFFFF"/>
                 </a:solidFill>
-                <a:latin typeface="Inter"/>
+                <a:latin typeface="Calibri"/>
               </a:rPr>
               <a:t>Five tools. Five silos.</a:t>
             </a:r>
@@ -22211,7 +22211,7 @@
                 <a:solidFill>
                   <a:srgbClr val="A9AFB6"/>
                 </a:solidFill>
-                <a:latin typeface="Inter"/>
+                <a:latin typeface="Calibri"/>
               </a:rPr>
               <a:t>The pieces are all there today — they just don't talk to each other.</a:t>
             </a:r>
@@ -22253,7 +22253,7 @@
                 <a:solidFill>
                   <a:srgbClr val="3A4A54"/>
                 </a:solidFill>
-                <a:latin typeface="Inter"/>
+                <a:latin typeface="Calibri"/>
               </a:rPr>
               <a:t>01 / 06</a:t>
             </a:r>
@@ -22365,7 +22365,7 @@
                 <a:solidFill>
                   <a:srgbClr val="F89739"/>
                 </a:solidFill>
-                <a:latin typeface="Inter"/>
+                <a:latin typeface="Calibri"/>
               </a:rPr>
               <a:t>THE SITUATION TODAY</a:t>
             </a:r>
@@ -22407,7 +22407,7 @@
                 <a:solidFill>
                   <a:srgbClr val="09131B"/>
                 </a:solidFill>
-                <a:latin typeface="Inter"/>
+                <a:latin typeface="Calibri"/>
               </a:rPr>
               <a:t>The estate runs on five disconnected tools</a:t>
             </a:r>
@@ -22497,7 +22497,7 @@
                 <a:solidFill>
                   <a:srgbClr val="F89739"/>
                 </a:solidFill>
-                <a:latin typeface="Inter"/>
+                <a:latin typeface="Calibri"/>
               </a:rPr>
               <a:t>DPRH</a:t>
             </a:r>
@@ -22516,7 +22516,7 @@
                 <a:solidFill>
                   <a:srgbClr val="09131B"/>
                 </a:solidFill>
-                <a:latin typeface="Inter"/>
+                <a:latin typeface="Calibri"/>
               </a:rPr>
               <a:t>Data Purchase Request Hub</a:t>
             </a:r>
@@ -22535,7 +22535,7 @@
                 <a:solidFill>
                   <a:srgbClr val="595959"/>
                 </a:solidFill>
-                <a:latin typeface="Inter"/>
+                <a:latin typeface="Calibri"/>
               </a:rPr>
               <a:t>Where data buys are raised and approved</a:t>
             </a:r>
@@ -22577,7 +22577,7 @@
                 <a:solidFill>
                   <a:srgbClr val="A9AFB6"/>
                 </a:solidFill>
-                <a:latin typeface="Inter"/>
+                <a:latin typeface="Calibri"/>
               </a:rPr>
               <a:t>·</a:t>
             </a:r>
@@ -22667,7 +22667,7 @@
                 <a:solidFill>
                   <a:srgbClr val="F89739"/>
                 </a:solidFill>
-                <a:latin typeface="Inter"/>
+                <a:latin typeface="Calibri"/>
               </a:rPr>
               <a:t>CATALOGUE</a:t>
             </a:r>
@@ -22686,7 +22686,7 @@
                 <a:solidFill>
                   <a:srgbClr val="09131B"/>
                 </a:solidFill>
-                <a:latin typeface="Inter"/>
+                <a:latin typeface="Calibri"/>
               </a:rPr>
               <a:t>Data Catalogue</a:t>
             </a:r>
@@ -22705,7 +22705,7 @@
                 <a:solidFill>
                   <a:srgbClr val="595959"/>
                 </a:solidFill>
-                <a:latin typeface="Inter"/>
+                <a:latin typeface="Calibri"/>
               </a:rPr>
               <a:t>The record of everything purchased</a:t>
             </a:r>
@@ -22747,7 +22747,7 @@
                 <a:solidFill>
                   <a:srgbClr val="A9AFB6"/>
                 </a:solidFill>
-                <a:latin typeface="Inter"/>
+                <a:latin typeface="Calibri"/>
               </a:rPr>
               <a:t>·</a:t>
             </a:r>
@@ -22837,7 +22837,7 @@
                 <a:solidFill>
                   <a:srgbClr val="F89739"/>
                 </a:solidFill>
-                <a:latin typeface="Inter"/>
+                <a:latin typeface="Calibri"/>
               </a:rPr>
               <a:t>KPI</a:t>
             </a:r>
@@ -22856,7 +22856,7 @@
                 <a:solidFill>
                   <a:srgbClr val="09131B"/>
                 </a:solidFill>
-                <a:latin typeface="Inter"/>
+                <a:latin typeface="Calibri"/>
               </a:rPr>
               <a:t>KPI Catalogue</a:t>
             </a:r>
@@ -22875,7 +22875,7 @@
                 <a:solidFill>
                   <a:srgbClr val="595959"/>
                 </a:solidFill>
-                <a:latin typeface="Inter"/>
+                <a:latin typeface="Calibri"/>
               </a:rPr>
               <a:t>The metrics built on that data</a:t>
             </a:r>
@@ -22917,7 +22917,7 @@
                 <a:solidFill>
                   <a:srgbClr val="A9AFB6"/>
                 </a:solidFill>
-                <a:latin typeface="Inter"/>
+                <a:latin typeface="Calibri"/>
               </a:rPr>
               <a:t>·</a:t>
             </a:r>
@@ -23007,7 +23007,7 @@
                 <a:solidFill>
                   <a:srgbClr val="F89739"/>
                 </a:solidFill>
-                <a:latin typeface="Inter"/>
+                <a:latin typeface="Calibri"/>
               </a:rPr>
               <a:t>VENDOR</a:t>
             </a:r>
@@ -23026,7 +23026,7 @@
                 <a:solidFill>
                   <a:srgbClr val="09131B"/>
                 </a:solidFill>
-                <a:latin typeface="Inter"/>
+                <a:latin typeface="Calibri"/>
               </a:rPr>
               <a:t>Vendor Hub</a:t>
             </a:r>
@@ -23045,7 +23045,7 @@
                 <a:solidFill>
                   <a:srgbClr val="595959"/>
                 </a:solidFill>
-                <a:latin typeface="Inter"/>
+                <a:latin typeface="Calibri"/>
               </a:rPr>
               <a:t>Who supplies what</a:t>
             </a:r>
@@ -23087,7 +23087,7 @@
                 <a:solidFill>
                   <a:srgbClr val="A9AFB6"/>
                 </a:solidFill>
-                <a:latin typeface="Inter"/>
+                <a:latin typeface="Calibri"/>
               </a:rPr>
               <a:t>·</a:t>
             </a:r>
@@ -23177,7 +23177,7 @@
                 <a:solidFill>
                   <a:srgbClr val="F89739"/>
                 </a:solidFill>
-                <a:latin typeface="Inter"/>
+                <a:latin typeface="Calibri"/>
               </a:rPr>
               <a:t>TPA</a:t>
             </a:r>
@@ -23196,7 +23196,7 @@
                 <a:solidFill>
                   <a:srgbClr val="09131B"/>
                 </a:solidFill>
-                <a:latin typeface="Inter"/>
+                <a:latin typeface="Calibri"/>
               </a:rPr>
               <a:t>TPA Hub</a:t>
             </a:r>
@@ -23215,7 +23215,7 @@
                 <a:solidFill>
                   <a:srgbClr val="595959"/>
                 </a:solidFill>
-                <a:latin typeface="Inter"/>
+                <a:latin typeface="Calibri"/>
               </a:rPr>
               <a:t>The agreements that govern sharing</a:t>
             </a:r>
@@ -23257,7 +23257,7 @@
                 <a:solidFill>
                   <a:srgbClr val="09131B"/>
                 </a:solidFill>
-                <a:latin typeface="Inter"/>
+                <a:latin typeface="Calibri"/>
               </a:rPr>
               <a:t>The problem isn't the tools — it's the gaps between them</a:t>
             </a:r>
@@ -23266,7 +23266,7 @@
                 <a:solidFill>
                   <a:srgbClr val="F89739"/>
                 </a:solidFill>
-                <a:latin typeface="Inter"/>
+                <a:latin typeface="Calibri"/>
               </a:rPr>
               <a:t>—  </a:t>
             </a:r>
@@ -23275,7 +23275,7 @@
                 <a:solidFill>
                   <a:srgbClr val="09131B"/>
                 </a:solidFill>
-                <a:latin typeface="Inter"/>
+                <a:latin typeface="Calibri"/>
               </a:rPr>
               <a:t>No single line of sight.</a:t>
             </a:r>
@@ -23284,7 +23284,7 @@
                 <a:solidFill>
                   <a:srgbClr val="595959"/>
                 </a:solidFill>
-                <a:latin typeface="Inter"/>
+                <a:latin typeface="Calibri"/>
               </a:rPr>
               <a:t> To answer 'do we already buy this?' someone manually checks the catalogue — if they remember to.</a:t>
             </a:r>
@@ -23303,7 +23303,7 @@
                 <a:solidFill>
                   <a:srgbClr val="F89739"/>
                 </a:solidFill>
-                <a:latin typeface="Inter"/>
+                <a:latin typeface="Calibri"/>
               </a:rPr>
               <a:t>—  </a:t>
             </a:r>
@@ -23312,7 +23312,7 @@
                 <a:solidFill>
                   <a:srgbClr val="09131B"/>
                 </a:solidFill>
-                <a:latin typeface="Inter"/>
+                <a:latin typeface="Calibri"/>
               </a:rPr>
               <a:t>Manual, reactive renewals.</a:t>
             </a:r>
@@ -23321,7 +23321,7 @@
                 <a:solidFill>
                   <a:srgbClr val="595959"/>
                 </a:solidFill>
-                <a:latin typeface="Inter"/>
+                <a:latin typeface="Calibri"/>
               </a:rPr>
               <a:t> Expiry tracking lives in spreadsheets and inboxes; agreements lapse or get renewed in a rush, losing leverage.</a:t>
             </a:r>
@@ -23340,7 +23340,7 @@
                 <a:solidFill>
                   <a:srgbClr val="F89739"/>
                 </a:solidFill>
-                <a:latin typeface="Inter"/>
+                <a:latin typeface="Calibri"/>
               </a:rPr>
               <a:t>—  </a:t>
             </a:r>
@@ -23349,7 +23349,7 @@
                 <a:solidFill>
                   <a:srgbClr val="09131B"/>
                 </a:solidFill>
-                <a:latin typeface="Inter"/>
+                <a:latin typeface="Calibri"/>
               </a:rPr>
               <a:t>Value is invisible.</a:t>
             </a:r>
@@ -23358,7 +23358,7 @@
                 <a:solidFill>
                   <a:srgbClr val="595959"/>
                 </a:solidFill>
-                <a:latin typeface="Inter"/>
+                <a:latin typeface="Calibri"/>
               </a:rPr>
               <a:t> Spend, quality and dependency sit in separate lists, so no one sees vendor concentration or what a metric actually rests on.</a:t>
             </a:r>
@@ -23377,7 +23377,7 @@
                 <a:solidFill>
                   <a:srgbClr val="F89739"/>
                 </a:solidFill>
-                <a:latin typeface="Inter"/>
+                <a:latin typeface="Calibri"/>
               </a:rPr>
               <a:t>—  </a:t>
             </a:r>
@@ -23386,7 +23386,7 @@
                 <a:solidFill>
                   <a:srgbClr val="09131B"/>
                 </a:solidFill>
-                <a:latin typeface="Inter"/>
+                <a:latin typeface="Calibri"/>
               </a:rPr>
               <a:t>Governance is effort, not default.</a:t>
             </a:r>
@@ -23395,7 +23395,7 @@
                 <a:solidFill>
                   <a:srgbClr val="595959"/>
                 </a:solidFill>
-                <a:latin typeface="Inter"/>
+                <a:latin typeface="Calibri"/>
               </a:rPr>
               <a:t> PII/PHI classification and lineage are done by hand, late, and inconsistently.</a:t>
             </a:r>
@@ -23481,7 +23481,7 @@
                 <a:solidFill>
                   <a:srgbClr val="A9AFB6"/>
                 </a:solidFill>
-                <a:latin typeface="Inter"/>
+                <a:latin typeface="Calibri"/>
               </a:rPr>
               <a:t>Cortex Atlas  ·  Illustrative prototype, synthetic data  ·  Confidential</a:t>
             </a:r>
@@ -23523,7 +23523,7 @@
                 <a:solidFill>
                   <a:srgbClr val="A9AFB6"/>
                 </a:solidFill>
-                <a:latin typeface="Inter"/>
+                <a:latin typeface="Calibri"/>
               </a:rPr>
               <a:t>2</a:t>
             </a:r>
@@ -23635,7 +23635,7 @@
                 <a:solidFill>
                   <a:srgbClr val="F89739"/>
                 </a:solidFill>
-                <a:latin typeface="Inter"/>
+                <a:latin typeface="Calibri"/>
               </a:rPr>
               <a:t>WHY IT MATTERS</a:t>
             </a:r>
@@ -23677,7 +23677,7 @@
                 <a:solidFill>
                   <a:srgbClr val="09131B"/>
                 </a:solidFill>
-                <a:latin typeface="Inter"/>
+                <a:latin typeface="Calibri"/>
               </a:rPr>
               <a:t>What the disconnect costs — four ways money and risk leak</a:t>
             </a:r>
@@ -23813,7 +23813,7 @@
                 <a:solidFill>
                   <a:srgbClr val="09131B"/>
                 </a:solidFill>
-                <a:latin typeface="Inter"/>
+                <a:latin typeface="Calibri"/>
               </a:rPr>
               <a:t>Duplicate buys</a:t>
             </a:r>
@@ -23832,7 +23832,7 @@
                 <a:solidFill>
                   <a:srgbClr val="595959"/>
                 </a:solidFill>
-                <a:latin typeface="Inter"/>
+                <a:latin typeface="Calibri"/>
               </a:rPr>
               <a:t>Teams re-purchase data the organisation already owns because there's no check at the point of request.</a:t>
             </a:r>
@@ -23874,7 +23874,7 @@
                 <a:solidFill>
                   <a:srgbClr val="9A5C12"/>
                 </a:solidFill>
-                <a:latin typeface="Inter"/>
+                <a:latin typeface="Calibri"/>
               </a:rPr>
               <a:t>AVOIDABLE SPEND</a:t>
             </a:r>
@@ -24010,7 +24010,7 @@
                 <a:solidFill>
                   <a:srgbClr val="09131B"/>
                 </a:solidFill>
-                <a:latin typeface="Inter"/>
+                <a:latin typeface="Calibri"/>
               </a:rPr>
               <a:t>Lapsed / rushed renewals</a:t>
             </a:r>
@@ -24029,7 +24029,7 @@
                 <a:solidFill>
                   <a:srgbClr val="595959"/>
                 </a:solidFill>
-                <a:latin typeface="Inter"/>
+                <a:latin typeface="Calibri"/>
               </a:rPr>
               <a:t>Agreements expire without warning, or renew under time pressure with no negotiating room.</a:t>
             </a:r>
@@ -24071,7 +24071,7 @@
                 <a:solidFill>
                   <a:srgbClr val="E8451C"/>
                 </a:solidFill>
-                <a:latin typeface="Inter"/>
+                <a:latin typeface="Calibri"/>
               </a:rPr>
               <a:t>LOST LEVERAGE + RISK</a:t>
             </a:r>
@@ -24207,7 +24207,7 @@
                 <a:solidFill>
                   <a:srgbClr val="09131B"/>
                 </a:solidFill>
-                <a:latin typeface="Inter"/>
+                <a:latin typeface="Calibri"/>
               </a:rPr>
               <a:t>Vendor over-dependence</a:t>
             </a:r>
@@ -24226,7 +24226,7 @@
                 <a:solidFill>
                   <a:srgbClr val="595959"/>
                 </a:solidFill>
-                <a:latin typeface="Inter"/>
+                <a:latin typeface="Calibri"/>
               </a:rPr>
               <a:t>Spend quietly concentrates in a few vendors with no substitutes — a single point of failure.</a:t>
             </a:r>
@@ -24268,7 +24268,7 @@
                 <a:solidFill>
                   <a:srgbClr val="9A5C12"/>
                 </a:solidFill>
-                <a:latin typeface="Inter"/>
+                <a:latin typeface="Calibri"/>
               </a:rPr>
               <a:t>CONCENTRATION RISK</a:t>
             </a:r>
@@ -24404,7 +24404,7 @@
                 <a:solidFill>
                   <a:srgbClr val="09131B"/>
                 </a:solidFill>
-                <a:latin typeface="Inter"/>
+                <a:latin typeface="Calibri"/>
               </a:rPr>
               <a:t>Audit exposure</a:t>
             </a:r>
@@ -24423,7 +24423,7 @@
                 <a:solidFill>
                   <a:srgbClr val="595959"/>
                 </a:solidFill>
-                <a:latin typeface="Inter"/>
+                <a:latin typeface="Calibri"/>
               </a:rPr>
               <a:t>Sensitive data isn't consistently classified and lineage is unclear when the auditor asks.</a:t>
             </a:r>
@@ -24465,7 +24465,7 @@
                 <a:solidFill>
                   <a:srgbClr val="E8451C"/>
                 </a:solidFill>
-                <a:latin typeface="Inter"/>
+                <a:latin typeface="Calibri"/>
               </a:rPr>
               <a:t>COMPLIANCE RISK</a:t>
             </a:r>
@@ -24507,7 +24507,7 @@
                 <a:solidFill>
                   <a:srgbClr val="09131B"/>
                 </a:solidFill>
-                <a:latin typeface="Inter"/>
+                <a:latin typeface="Calibri"/>
               </a:rPr>
               <a:t>None of this is a people problem. It's a structure problem — and structure is exactly what a connected platform fixes.</a:t>
             </a:r>
@@ -24593,7 +24593,7 @@
                 <a:solidFill>
                   <a:srgbClr val="A9AFB6"/>
                 </a:solidFill>
-                <a:latin typeface="Inter"/>
+                <a:latin typeface="Calibri"/>
               </a:rPr>
               <a:t>Cortex Atlas  ·  Illustrative prototype, synthetic data  ·  Confidential</a:t>
             </a:r>
@@ -24635,7 +24635,7 @@
                 <a:solidFill>
                   <a:srgbClr val="A9AFB6"/>
                 </a:solidFill>
-                <a:latin typeface="Inter"/>
+                <a:latin typeface="Calibri"/>
               </a:rPr>
               <a:t>3</a:t>
             </a:r>
@@ -24747,7 +24747,7 @@
                 <a:solidFill>
                   <a:srgbClr val="F89739"/>
                 </a:solidFill>
-                <a:latin typeface="Inter"/>
+                <a:latin typeface="Calibri"/>
               </a:rPr>
               <a:t>THE SOLUTION</a:t>
             </a:r>
@@ -24789,7 +24789,7 @@
                 <a:solidFill>
                   <a:srgbClr val="FFFFFF"/>
                 </a:solidFill>
-                <a:latin typeface="Inter"/>
+                <a:latin typeface="Calibri"/>
               </a:rPr>
               <a:t>One connected estate</a:t>
             </a:r>
@@ -24831,7 +24831,7 @@
                 <a:solidFill>
                   <a:srgbClr val="A9AFB6"/>
                 </a:solidFill>
-                <a:latin typeface="Inter"/>
+                <a:latin typeface="Calibri"/>
               </a:rPr>
               <a:t>A purchase request becomes a catalogued asset, measured by KPIs, supplied by a vendor, governed by an agreement — and Atlas sees all of it.</a:t>
             </a:r>
@@ -24873,7 +24873,7 @@
                 <a:solidFill>
                   <a:srgbClr val="3A4A54"/>
                 </a:solidFill>
-                <a:latin typeface="Inter"/>
+                <a:latin typeface="Calibri"/>
               </a:rPr>
               <a:t>02 / 06</a:t>
             </a:r>
@@ -24985,7 +24985,7 @@
                 <a:solidFill>
                   <a:srgbClr val="F89739"/>
                 </a:solidFill>
-                <a:latin typeface="Inter"/>
+                <a:latin typeface="Calibri"/>
               </a:rPr>
               <a:t>THE BIG IDEA</a:t>
             </a:r>
@@ -25027,7 +25027,7 @@
                 <a:solidFill>
                   <a:srgbClr val="09131B"/>
                 </a:solidFill>
-                <a:latin typeface="Inter"/>
+                <a:latin typeface="Calibri"/>
               </a:rPr>
               <a:t>Cortex Atlas: the five tools as one estate</a:t>
             </a:r>
@@ -25117,7 +25117,7 @@
                 <a:solidFill>
                   <a:srgbClr val="F89739"/>
                 </a:solidFill>
-                <a:latin typeface="Inter"/>
+                <a:latin typeface="Calibri"/>
               </a:rPr>
               <a:t>DPRH</a:t>
             </a:r>
@@ -25136,7 +25136,7 @@
                 <a:solidFill>
                   <a:srgbClr val="09131B"/>
                 </a:solidFill>
-                <a:latin typeface="Inter"/>
+                <a:latin typeface="Calibri"/>
               </a:rPr>
               <a:t>Data Requests</a:t>
             </a:r>
@@ -25178,7 +25178,7 @@
                 <a:solidFill>
                   <a:srgbClr val="F89739"/>
                 </a:solidFill>
-                <a:latin typeface="Inter"/>
+                <a:latin typeface="Calibri"/>
               </a:rPr>
               <a:t>→</a:t>
             </a:r>
@@ -25268,7 +25268,7 @@
                 <a:solidFill>
                   <a:srgbClr val="F89739"/>
                 </a:solidFill>
-                <a:latin typeface="Inter"/>
+                <a:latin typeface="Calibri"/>
               </a:rPr>
               <a:t>ASSET</a:t>
             </a:r>
@@ -25287,7 +25287,7 @@
                 <a:solidFill>
                   <a:srgbClr val="09131B"/>
                 </a:solidFill>
-                <a:latin typeface="Inter"/>
+                <a:latin typeface="Calibri"/>
               </a:rPr>
               <a:t>Data Catalogue</a:t>
             </a:r>
@@ -25329,7 +25329,7 @@
                 <a:solidFill>
                   <a:srgbClr val="F89739"/>
                 </a:solidFill>
-                <a:latin typeface="Inter"/>
+                <a:latin typeface="Calibri"/>
               </a:rPr>
               <a:t>→</a:t>
             </a:r>
@@ -25419,7 +25419,7 @@
                 <a:solidFill>
                   <a:srgbClr val="F89739"/>
                 </a:solidFill>
-                <a:latin typeface="Inter"/>
+                <a:latin typeface="Calibri"/>
               </a:rPr>
               <a:t>METRIC</a:t>
             </a:r>
@@ -25438,7 +25438,7 @@
                 <a:solidFill>
                   <a:srgbClr val="09131B"/>
                 </a:solidFill>
-                <a:latin typeface="Inter"/>
+                <a:latin typeface="Calibri"/>
               </a:rPr>
               <a:t>KPI Catalogue</a:t>
             </a:r>
@@ -25480,7 +25480,7 @@
                 <a:solidFill>
                   <a:srgbClr val="F89739"/>
                 </a:solidFill>
-                <a:latin typeface="Inter"/>
+                <a:latin typeface="Calibri"/>
               </a:rPr>
               <a:t>→</a:t>
             </a:r>
@@ -25570,7 +25570,7 @@
                 <a:solidFill>
                   <a:srgbClr val="F89739"/>
                 </a:solidFill>
-                <a:latin typeface="Inter"/>
+                <a:latin typeface="Calibri"/>
               </a:rPr>
               <a:t>VENDOR</a:t>
             </a:r>
@@ -25589,7 +25589,7 @@
                 <a:solidFill>
                   <a:srgbClr val="09131B"/>
                 </a:solidFill>
-                <a:latin typeface="Inter"/>
+                <a:latin typeface="Calibri"/>
               </a:rPr>
               <a:t>Vendor Hub</a:t>
             </a:r>
@@ -25631,7 +25631,7 @@
                 <a:solidFill>
                   <a:srgbClr val="F89739"/>
                 </a:solidFill>
-                <a:latin typeface="Inter"/>
+                <a:latin typeface="Calibri"/>
               </a:rPr>
               <a:t>→</a:t>
             </a:r>
@@ -25721,7 +25721,7 @@
                 <a:solidFill>
                   <a:srgbClr val="F89739"/>
                 </a:solidFill>
-                <a:latin typeface="Inter"/>
+                <a:latin typeface="Calibri"/>
               </a:rPr>
               <a:t>AGREEMENT</a:t>
             </a:r>
@@ -25740,7 +25740,7 @@
                 <a:solidFill>
                   <a:srgbClr val="09131B"/>
                 </a:solidFill>
-                <a:latin typeface="Inter"/>
+                <a:latin typeface="Calibri"/>
               </a:rPr>
               <a:t>TPA Hub</a:t>
             </a:r>
@@ -25782,7 +25782,7 @@
                 <a:solidFill>
                   <a:srgbClr val="09131B"/>
                 </a:solidFill>
-                <a:latin typeface="Inter"/>
+                <a:latin typeface="Calibri"/>
               </a:rPr>
               <a:t>Real links, not labels — every connection is clickable</a:t>
             </a:r>
@@ -25872,7 +25872,7 @@
                 <a:solidFill>
                   <a:srgbClr val="09131B"/>
                 </a:solidFill>
-                <a:latin typeface="Inter"/>
+                <a:latin typeface="Calibri"/>
               </a:rPr>
               <a:t>From a request</a:t>
             </a:r>
@@ -25891,7 +25891,7 @@
                 <a:solidFill>
                   <a:srgbClr val="595959"/>
                 </a:solidFill>
-                <a:latin typeface="Inter"/>
+                <a:latin typeface="Calibri"/>
               </a:rPr>
               <a:t>jump to the catalogue entry it creates</a:t>
             </a:r>
@@ -25981,7 +25981,7 @@
                 <a:solidFill>
                   <a:srgbClr val="09131B"/>
                 </a:solidFill>
-                <a:latin typeface="Inter"/>
+                <a:latin typeface="Calibri"/>
               </a:rPr>
               <a:t>From an asset</a:t>
             </a:r>
@@ -26000,7 +26000,7 @@
                 <a:solidFill>
                   <a:srgbClr val="595959"/>
                 </a:solidFill>
-                <a:latin typeface="Inter"/>
+                <a:latin typeface="Calibri"/>
               </a:rPr>
               <a:t>jump to its KPIs, its vendor, its agreement</a:t>
             </a:r>
@@ -26090,7 +26090,7 @@
                 <a:solidFill>
                   <a:srgbClr val="09131B"/>
                 </a:solidFill>
-                <a:latin typeface="Inter"/>
+                <a:latin typeface="Calibri"/>
               </a:rPr>
               <a:t>From a KPI</a:t>
             </a:r>
@@ -26109,7 +26109,7 @@
                 <a:solidFill>
                   <a:srgbClr val="595959"/>
                 </a:solidFill>
-                <a:latin typeface="Inter"/>
+                <a:latin typeface="Calibri"/>
               </a:rPr>
               <a:t>trace the exact asset and vendor it depends on</a:t>
             </a:r>
@@ -26199,7 +26199,7 @@
                 <a:solidFill>
                   <a:srgbClr val="09131B"/>
                 </a:solidFill>
-                <a:latin typeface="Inter"/>
+                <a:latin typeface="Calibri"/>
               </a:rPr>
               <a:t>From an agreement</a:t>
             </a:r>
@@ -26218,7 +26218,7 @@
                 <a:solidFill>
                   <a:srgbClr val="595959"/>
                 </a:solidFill>
-                <a:latin typeface="Inter"/>
+                <a:latin typeface="Calibri"/>
               </a:rPr>
               <a:t>see the asset and the strategic KPI behind it</a:t>
             </a:r>
@@ -26304,7 +26304,7 @@
                 <a:solidFill>
                   <a:srgbClr val="A9AFB6"/>
                 </a:solidFill>
-                <a:latin typeface="Inter"/>
+                <a:latin typeface="Calibri"/>
               </a:rPr>
               <a:t>Cortex Atlas  ·  Illustrative prototype, synthetic data  ·  Confidential</a:t>
             </a:r>
@@ -26346,7 +26346,7 @@
                 <a:solidFill>
                   <a:srgbClr val="A9AFB6"/>
                 </a:solidFill>
-                <a:latin typeface="Inter"/>
+                <a:latin typeface="Calibri"/>
               </a:rPr>
               <a:t>4</a:t>
             </a:r>
@@ -26458,7 +26458,7 @@
                 <a:solidFill>
                   <a:srgbClr val="F89739"/>
                 </a:solidFill>
-                <a:latin typeface="Inter"/>
+                <a:latin typeface="Calibri"/>
               </a:rPr>
               <a:t>HOW IT WORKS</a:t>
             </a:r>
@@ -26500,7 +26500,7 @@
                 <a:solidFill>
                   <a:srgbClr val="09131B"/>
                 </a:solidFill>
-                <a:latin typeface="Inter"/>
+                <a:latin typeface="Calibri"/>
               </a:rPr>
               <a:t>Three layers, one tool</a:t>
             </a:r>
@@ -26682,7 +26682,7 @@
                 <a:solidFill>
                   <a:srgbClr val="FFFFFF"/>
                 </a:solidFill>
-                <a:latin typeface="Inter"/>
+                <a:latin typeface="Calibri"/>
               </a:rPr>
               <a:t>01</a:t>
             </a:r>
@@ -26724,7 +26724,7 @@
                 <a:solidFill>
                   <a:srgbClr val="09131B"/>
                 </a:solidFill>
-                <a:latin typeface="Inter"/>
+                <a:latin typeface="Calibri"/>
               </a:rPr>
               <a:t>Estate</a:t>
             </a:r>
@@ -26743,7 +26743,7 @@
                 <a:solidFill>
                   <a:srgbClr val="0563C1"/>
                 </a:solidFill>
-                <a:latin typeface="Inter"/>
+                <a:latin typeface="Calibri"/>
               </a:rPr>
               <a:t>The five tools, faithful to how they work today</a:t>
             </a:r>
@@ -26762,7 +26762,7 @@
                 <a:solidFill>
                   <a:srgbClr val="595959"/>
                 </a:solidFill>
-                <a:latin typeface="Inter"/>
+                <a:latin typeface="Calibri"/>
               </a:rPr>
               <a:t>Combined role-gated request form · full catalogue record · KPI registry · vendor inventory · agreement register. The trustworthy foundation.</a:t>
             </a:r>
@@ -26944,7 +26944,7 @@
                 <a:solidFill>
                   <a:srgbClr val="FFFFFF"/>
                 </a:solidFill>
-                <a:latin typeface="Inter"/>
+                <a:latin typeface="Calibri"/>
               </a:rPr>
               <a:t>02</a:t>
             </a:r>
@@ -26986,7 +26986,7 @@
                 <a:solidFill>
                   <a:srgbClr val="09131B"/>
                 </a:solidFill>
-                <a:latin typeface="Inter"/>
+                <a:latin typeface="Calibri"/>
               </a:rPr>
               <a:t>Automation</a:t>
             </a:r>
@@ -27005,7 +27005,7 @@
                 <a:solidFill>
                   <a:srgbClr val="9A5C12"/>
                 </a:solidFill>
-                <a:latin typeface="Inter"/>
+                <a:latin typeface="Calibri"/>
               </a:rPr>
               <a:t>The work the platform does for you</a:t>
             </a:r>
@@ -27024,7 +27024,7 @@
                 <a:solidFill>
                   <a:srgbClr val="595959"/>
                 </a:solidFill>
-                <a:latin typeface="Inter"/>
+                <a:latin typeface="Calibri"/>
               </a:rPr>
               <a:t>30/60/90-day renewal reminders · approved request auto-writes to the catalogue · renewals pre-fill from it · PII/PHI auto-classification · duplicate-buy detection at intake.</a:t>
             </a:r>
@@ -27206,7 +27206,7 @@
                 <a:solidFill>
                   <a:srgbClr val="FFFFFF"/>
                 </a:solidFill>
-                <a:latin typeface="Inter"/>
+                <a:latin typeface="Calibri"/>
               </a:rPr>
               <a:t>03</a:t>
             </a:r>
@@ -27248,7 +27248,7 @@
                 <a:solidFill>
                   <a:srgbClr val="09131B"/>
                 </a:solidFill>
-                <a:latin typeface="Inter"/>
+                <a:latin typeface="Calibri"/>
               </a:rPr>
               <a:t>Intelligence</a:t>
             </a:r>
@@ -27267,7 +27267,7 @@
                 <a:solidFill>
                   <a:srgbClr val="1E7F4F"/>
                 </a:solidFill>
-                <a:latin typeface="Inter"/>
+                <a:latin typeface="Calibri"/>
               </a:rPr>
               <a:t>The decision layer on top</a:t>
             </a:r>
@@ -27286,7 +27286,7 @@
                 <a:solidFill>
                   <a:srgbClr val="595959"/>
                 </a:solidFill>
-                <a:latin typeface="Inter"/>
+                <a:latin typeface="Calibri"/>
               </a:rPr>
               <a:t>Cross-tool signals · renewal prediction · vendor concentration &amp; value analytics (Vendor Hub Plus) · natural-language Ask Atlas across the estate.</a:t>
             </a:r>
@@ -27372,7 +27372,7 @@
                 <a:solidFill>
                   <a:srgbClr val="A9AFB6"/>
                 </a:solidFill>
-                <a:latin typeface="Inter"/>
+                <a:latin typeface="Calibri"/>
               </a:rPr>
               <a:t>Cortex Atlas  ·  Illustrative prototype, synthetic data  ·  Confidential</a:t>
             </a:r>
@@ -27414,7 +27414,7 @@
                 <a:solidFill>
                   <a:srgbClr val="A9AFB6"/>
                 </a:solidFill>
-                <a:latin typeface="Inter"/>
+                <a:latin typeface="Calibri"/>
               </a:rPr>
               <a:t>5</a:t>
             </a:r>
@@ -27526,7 +27526,7 @@
                 <a:solidFill>
                   <a:srgbClr val="F89739"/>
                 </a:solidFill>
-                <a:latin typeface="Inter"/>
+                <a:latin typeface="Calibri"/>
               </a:rPr>
               <a:t>INSIDE THE PLATFORM</a:t>
             </a:r>
@@ -27568,7 +27568,7 @@
                 <a:solidFill>
                   <a:srgbClr val="FFFFFF"/>
                 </a:solidFill>
-                <a:latin typeface="Inter"/>
+                <a:latin typeface="Calibri"/>
               </a:rPr>
               <a:t>A guided walk through the five tools</a:t>
             </a:r>
@@ -27610,7 +27610,7 @@
                 <a:solidFill>
                   <a:srgbClr val="A9AFB6"/>
                 </a:solidFill>
-                <a:latin typeface="Inter"/>
+                <a:latin typeface="Calibri"/>
               </a:rPr>
               <a:t>Each tool keeps its real-world job — then carries the automation and intelligence that belong to it.</a:t>
             </a:r>
@@ -27652,7 +27652,7 @@
                 <a:solidFill>
                   <a:srgbClr val="3A4A54"/>
                 </a:solidFill>
-                <a:latin typeface="Inter"/>
+                <a:latin typeface="Calibri"/>
               </a:rPr>
               <a:t>03 / 06</a:t>
             </a:r>

</xml_diff>